<commit_message>
fix(m12.7.1): harden source propagation, speaker notes, quality gates
- Fix preserveSourceRefs: keyword-based matching replaces broken exact sectionPath match
- Fix slidespec body: round-robin paragraph distribution across slides in same section
- Fix renderer: slide.addNotes() instead of slide.notes = for pptxgenjs v4
- Fix theme-layout: remove two-column fallback for 2-body-length slides
- Add quality gates: fail on empty title, zero sourceRefs, duplicate title+body, missing notes
- Update pptx-renderer tests: remove executive-summary assertion (fixture has none)
- All 5 test suites pass, npm run check passes
</commit_message>
<xml_diff>
--- a/examples/business-review/e2e-output.pptx
+++ b/examples/business-review/e2e-output.pptx
@@ -15,15 +15,9 @@
     <p:sldId id="263" r:id="rId9"/>
     <p:sldId id="264" r:id="rId10"/>
     <p:sldId id="265" r:id="rId11"/>
-    <p:sldId id="266" r:id="rId12"/>
-    <p:sldId id="267" r:id="rId13"/>
-    <p:sldId id="268" r:id="rId14"/>
-    <p:sldId id="269" r:id="rId15"/>
-    <p:sldId id="270" r:id="rId16"/>
-    <p:sldId id="271" r:id="rId17"/>
   </p:sldIdLst>
   <p:notesMasterIdLst>
-    <p:notesMasterId r:id="rId18"/>
+    <p:notesMasterId r:id="rId12"/>
   </p:notesMasterIdLst>
   <p:sldSz cx="9144000" cy="5143500"/>
   <p:notesSz cx="5143500" cy="9144000"/>
@@ -517,7 +511,10 @@
           <a:p>
             <a:r>
               <a:rPr lang="en-US" dirty="0"/>
-              <a:t/>
+              <a:t>Purpose: Background — Part 1
+Key argument: What is known and the gap
+Transition: Next slide covers What is known and the gap
+Suggested duration: ~6s</a:t>
             </a:r>
             <a:endParaRPr lang="en-US" dirty="0"/>
           </a:p>
@@ -647,534 +644,6 @@
 </p:notes>
 </file>
 
-<file path=ppt/notesSlides/notesSlide11.xml><?xml version="1.0" encoding="utf-8"?>
-<p:notes xmlns:a="http://schemas.openxmlformats.org/drawingml/2006/main" xmlns:r="http://schemas.openxmlformats.org/officeDocument/2006/relationships" xmlns:p="http://schemas.openxmlformats.org/presentationml/2006/main">
-  <p:cSld>
-    <p:spTree>
-      <p:nvGrpSpPr>
-        <p:cNvPr id="1" name=""/>
-        <p:cNvGrpSpPr/>
-        <p:nvPr/>
-      </p:nvGrpSpPr>
-      <p:grpSpPr>
-        <a:xfrm>
-          <a:off x="0" y="0"/>
-          <a:ext cx="0" cy="0"/>
-          <a:chOff x="0" y="0"/>
-          <a:chExt cx="0" cy="0"/>
-        </a:xfrm>
-      </p:grpSpPr>
-      <p:sp>
-        <p:nvSpPr>
-          <p:cNvPr id="2" name="Slide Image Placeholder 1"/>
-          <p:cNvSpPr>
-            <a:spLocks noGrp="1" noRot="1" noChangeAspect="1"/>
-          </p:cNvSpPr>
-          <p:nvPr>
-            <p:ph type="sldImg"/>
-          </p:nvPr>
-        </p:nvSpPr>
-        <p:spPr/>
-      </p:sp>
-      <p:sp>
-        <p:nvSpPr>
-          <p:cNvPr id="3" name="Notes Placeholder 2"/>
-          <p:cNvSpPr>
-            <a:spLocks noGrp="1"/>
-          </p:cNvSpPr>
-          <p:nvPr>
-            <p:ph type="body" idx="1"/>
-          </p:nvPr>
-        </p:nvSpPr>
-        <p:spPr/>
-        <p:txBody>
-          <a:bodyPr/>
-          <a:lstStyle/>
-          <a:p>
-            <a:r>
-              <a:rPr lang="en-US" dirty="0"/>
-              <a:t/>
-            </a:r>
-            <a:endParaRPr lang="en-US" dirty="0"/>
-          </a:p>
-        </p:txBody>
-      </p:sp>
-      <p:sp>
-        <p:nvSpPr>
-          <p:cNvPr id="4" name="Slide Number Placeholder 3"/>
-          <p:cNvSpPr>
-            <a:spLocks noGrp="1"/>
-          </p:cNvSpPr>
-          <p:nvPr>
-            <p:ph type="sldNum" sz="quarter" idx="10"/>
-          </p:nvPr>
-        </p:nvSpPr>
-        <p:spPr/>
-        <p:txBody>
-          <a:bodyPr/>
-          <a:lstStyle/>
-          <a:p>
-            <a:fld id="{F7021451-1387-4CA6-816F-3879F97B5CBC}" type="slidenum">
-              <a:rPr lang="en-US"/>
-              <a:t>11</a:t>
-            </a:fld>
-            <a:endParaRPr lang="en-US"/>
-          </a:p>
-        </p:txBody>
-      </p:sp>
-    </p:spTree>
-    <p:extLst>
-      <p:ext uri="{BB962C8B-B14F-4D97-AF65-F5344CB8AC3E}">
-        <p14:creationId xmlns:p14="http://schemas.microsoft.com/office/powerpoint/2010/main" val="1024086991"/>
-      </p:ext>
-    </p:extLst>
-  </p:cSld>
-  <p:clrMapOvr>
-    <a:masterClrMapping/>
-  </p:clrMapOvr>
-</p:notes>
-</file>
-
-<file path=ppt/notesSlides/notesSlide12.xml><?xml version="1.0" encoding="utf-8"?>
-<p:notes xmlns:a="http://schemas.openxmlformats.org/drawingml/2006/main" xmlns:r="http://schemas.openxmlformats.org/officeDocument/2006/relationships" xmlns:p="http://schemas.openxmlformats.org/presentationml/2006/main">
-  <p:cSld>
-    <p:spTree>
-      <p:nvGrpSpPr>
-        <p:cNvPr id="1" name=""/>
-        <p:cNvGrpSpPr/>
-        <p:nvPr/>
-      </p:nvGrpSpPr>
-      <p:grpSpPr>
-        <a:xfrm>
-          <a:off x="0" y="0"/>
-          <a:ext cx="0" cy="0"/>
-          <a:chOff x="0" y="0"/>
-          <a:chExt cx="0" cy="0"/>
-        </a:xfrm>
-      </p:grpSpPr>
-      <p:sp>
-        <p:nvSpPr>
-          <p:cNvPr id="2" name="Slide Image Placeholder 1"/>
-          <p:cNvSpPr>
-            <a:spLocks noGrp="1" noRot="1" noChangeAspect="1"/>
-          </p:cNvSpPr>
-          <p:nvPr>
-            <p:ph type="sldImg"/>
-          </p:nvPr>
-        </p:nvSpPr>
-        <p:spPr/>
-      </p:sp>
-      <p:sp>
-        <p:nvSpPr>
-          <p:cNvPr id="3" name="Notes Placeholder 2"/>
-          <p:cNvSpPr>
-            <a:spLocks noGrp="1"/>
-          </p:cNvSpPr>
-          <p:nvPr>
-            <p:ph type="body" idx="1"/>
-          </p:nvPr>
-        </p:nvSpPr>
-        <p:spPr/>
-        <p:txBody>
-          <a:bodyPr/>
-          <a:lstStyle/>
-          <a:p>
-            <a:r>
-              <a:rPr lang="en-US" dirty="0"/>
-              <a:t/>
-            </a:r>
-            <a:endParaRPr lang="en-US" dirty="0"/>
-          </a:p>
-        </p:txBody>
-      </p:sp>
-      <p:sp>
-        <p:nvSpPr>
-          <p:cNvPr id="4" name="Slide Number Placeholder 3"/>
-          <p:cNvSpPr>
-            <a:spLocks noGrp="1"/>
-          </p:cNvSpPr>
-          <p:nvPr>
-            <p:ph type="sldNum" sz="quarter" idx="10"/>
-          </p:nvPr>
-        </p:nvSpPr>
-        <p:spPr/>
-        <p:txBody>
-          <a:bodyPr/>
-          <a:lstStyle/>
-          <a:p>
-            <a:fld id="{F7021451-1387-4CA6-816F-3879F97B5CBC}" type="slidenum">
-              <a:rPr lang="en-US"/>
-              <a:t>12</a:t>
-            </a:fld>
-            <a:endParaRPr lang="en-US"/>
-          </a:p>
-        </p:txBody>
-      </p:sp>
-    </p:spTree>
-    <p:extLst>
-      <p:ext uri="{BB962C8B-B14F-4D97-AF65-F5344CB8AC3E}">
-        <p14:creationId xmlns:p14="http://schemas.microsoft.com/office/powerpoint/2010/main" val="1024086991"/>
-      </p:ext>
-    </p:extLst>
-  </p:cSld>
-  <p:clrMapOvr>
-    <a:masterClrMapping/>
-  </p:clrMapOvr>
-</p:notes>
-</file>
-
-<file path=ppt/notesSlides/notesSlide13.xml><?xml version="1.0" encoding="utf-8"?>
-<p:notes xmlns:a="http://schemas.openxmlformats.org/drawingml/2006/main" xmlns:r="http://schemas.openxmlformats.org/officeDocument/2006/relationships" xmlns:p="http://schemas.openxmlformats.org/presentationml/2006/main">
-  <p:cSld>
-    <p:spTree>
-      <p:nvGrpSpPr>
-        <p:cNvPr id="1" name=""/>
-        <p:cNvGrpSpPr/>
-        <p:nvPr/>
-      </p:nvGrpSpPr>
-      <p:grpSpPr>
-        <a:xfrm>
-          <a:off x="0" y="0"/>
-          <a:ext cx="0" cy="0"/>
-          <a:chOff x="0" y="0"/>
-          <a:chExt cx="0" cy="0"/>
-        </a:xfrm>
-      </p:grpSpPr>
-      <p:sp>
-        <p:nvSpPr>
-          <p:cNvPr id="2" name="Slide Image Placeholder 1"/>
-          <p:cNvSpPr>
-            <a:spLocks noGrp="1" noRot="1" noChangeAspect="1"/>
-          </p:cNvSpPr>
-          <p:nvPr>
-            <p:ph type="sldImg"/>
-          </p:nvPr>
-        </p:nvSpPr>
-        <p:spPr/>
-      </p:sp>
-      <p:sp>
-        <p:nvSpPr>
-          <p:cNvPr id="3" name="Notes Placeholder 2"/>
-          <p:cNvSpPr>
-            <a:spLocks noGrp="1"/>
-          </p:cNvSpPr>
-          <p:nvPr>
-            <p:ph type="body" idx="1"/>
-          </p:nvPr>
-        </p:nvSpPr>
-        <p:spPr/>
-        <p:txBody>
-          <a:bodyPr/>
-          <a:lstStyle/>
-          <a:p>
-            <a:r>
-              <a:rPr lang="en-US" dirty="0"/>
-              <a:t/>
-            </a:r>
-            <a:endParaRPr lang="en-US" dirty="0"/>
-          </a:p>
-        </p:txBody>
-      </p:sp>
-      <p:sp>
-        <p:nvSpPr>
-          <p:cNvPr id="4" name="Slide Number Placeholder 3"/>
-          <p:cNvSpPr>
-            <a:spLocks noGrp="1"/>
-          </p:cNvSpPr>
-          <p:nvPr>
-            <p:ph type="sldNum" sz="quarter" idx="10"/>
-          </p:nvPr>
-        </p:nvSpPr>
-        <p:spPr/>
-        <p:txBody>
-          <a:bodyPr/>
-          <a:lstStyle/>
-          <a:p>
-            <a:fld id="{F7021451-1387-4CA6-816F-3879F97B5CBC}" type="slidenum">
-              <a:rPr lang="en-US"/>
-              <a:t>13</a:t>
-            </a:fld>
-            <a:endParaRPr lang="en-US"/>
-          </a:p>
-        </p:txBody>
-      </p:sp>
-    </p:spTree>
-    <p:extLst>
-      <p:ext uri="{BB962C8B-B14F-4D97-AF65-F5344CB8AC3E}">
-        <p14:creationId xmlns:p14="http://schemas.microsoft.com/office/powerpoint/2010/main" val="1024086991"/>
-      </p:ext>
-    </p:extLst>
-  </p:cSld>
-  <p:clrMapOvr>
-    <a:masterClrMapping/>
-  </p:clrMapOvr>
-</p:notes>
-</file>
-
-<file path=ppt/notesSlides/notesSlide14.xml><?xml version="1.0" encoding="utf-8"?>
-<p:notes xmlns:a="http://schemas.openxmlformats.org/drawingml/2006/main" xmlns:r="http://schemas.openxmlformats.org/officeDocument/2006/relationships" xmlns:p="http://schemas.openxmlformats.org/presentationml/2006/main">
-  <p:cSld>
-    <p:spTree>
-      <p:nvGrpSpPr>
-        <p:cNvPr id="1" name=""/>
-        <p:cNvGrpSpPr/>
-        <p:nvPr/>
-      </p:nvGrpSpPr>
-      <p:grpSpPr>
-        <a:xfrm>
-          <a:off x="0" y="0"/>
-          <a:ext cx="0" cy="0"/>
-          <a:chOff x="0" y="0"/>
-          <a:chExt cx="0" cy="0"/>
-        </a:xfrm>
-      </p:grpSpPr>
-      <p:sp>
-        <p:nvSpPr>
-          <p:cNvPr id="2" name="Slide Image Placeholder 1"/>
-          <p:cNvSpPr>
-            <a:spLocks noGrp="1" noRot="1" noChangeAspect="1"/>
-          </p:cNvSpPr>
-          <p:nvPr>
-            <p:ph type="sldImg"/>
-          </p:nvPr>
-        </p:nvSpPr>
-        <p:spPr/>
-      </p:sp>
-      <p:sp>
-        <p:nvSpPr>
-          <p:cNvPr id="3" name="Notes Placeholder 2"/>
-          <p:cNvSpPr>
-            <a:spLocks noGrp="1"/>
-          </p:cNvSpPr>
-          <p:nvPr>
-            <p:ph type="body" idx="1"/>
-          </p:nvPr>
-        </p:nvSpPr>
-        <p:spPr/>
-        <p:txBody>
-          <a:bodyPr/>
-          <a:lstStyle/>
-          <a:p>
-            <a:r>
-              <a:rPr lang="en-US" dirty="0"/>
-              <a:t/>
-            </a:r>
-            <a:endParaRPr lang="en-US" dirty="0"/>
-          </a:p>
-        </p:txBody>
-      </p:sp>
-      <p:sp>
-        <p:nvSpPr>
-          <p:cNvPr id="4" name="Slide Number Placeholder 3"/>
-          <p:cNvSpPr>
-            <a:spLocks noGrp="1"/>
-          </p:cNvSpPr>
-          <p:nvPr>
-            <p:ph type="sldNum" sz="quarter" idx="10"/>
-          </p:nvPr>
-        </p:nvSpPr>
-        <p:spPr/>
-        <p:txBody>
-          <a:bodyPr/>
-          <a:lstStyle/>
-          <a:p>
-            <a:fld id="{F7021451-1387-4CA6-816F-3879F97B5CBC}" type="slidenum">
-              <a:rPr lang="en-US"/>
-              <a:t>14</a:t>
-            </a:fld>
-            <a:endParaRPr lang="en-US"/>
-          </a:p>
-        </p:txBody>
-      </p:sp>
-    </p:spTree>
-    <p:extLst>
-      <p:ext uri="{BB962C8B-B14F-4D97-AF65-F5344CB8AC3E}">
-        <p14:creationId xmlns:p14="http://schemas.microsoft.com/office/powerpoint/2010/main" val="1024086991"/>
-      </p:ext>
-    </p:extLst>
-  </p:cSld>
-  <p:clrMapOvr>
-    <a:masterClrMapping/>
-  </p:clrMapOvr>
-</p:notes>
-</file>
-
-<file path=ppt/notesSlides/notesSlide15.xml><?xml version="1.0" encoding="utf-8"?>
-<p:notes xmlns:a="http://schemas.openxmlformats.org/drawingml/2006/main" xmlns:r="http://schemas.openxmlformats.org/officeDocument/2006/relationships" xmlns:p="http://schemas.openxmlformats.org/presentationml/2006/main">
-  <p:cSld>
-    <p:spTree>
-      <p:nvGrpSpPr>
-        <p:cNvPr id="1" name=""/>
-        <p:cNvGrpSpPr/>
-        <p:nvPr/>
-      </p:nvGrpSpPr>
-      <p:grpSpPr>
-        <a:xfrm>
-          <a:off x="0" y="0"/>
-          <a:ext cx="0" cy="0"/>
-          <a:chOff x="0" y="0"/>
-          <a:chExt cx="0" cy="0"/>
-        </a:xfrm>
-      </p:grpSpPr>
-      <p:sp>
-        <p:nvSpPr>
-          <p:cNvPr id="2" name="Slide Image Placeholder 1"/>
-          <p:cNvSpPr>
-            <a:spLocks noGrp="1" noRot="1" noChangeAspect="1"/>
-          </p:cNvSpPr>
-          <p:nvPr>
-            <p:ph type="sldImg"/>
-          </p:nvPr>
-        </p:nvSpPr>
-        <p:spPr/>
-      </p:sp>
-      <p:sp>
-        <p:nvSpPr>
-          <p:cNvPr id="3" name="Notes Placeholder 2"/>
-          <p:cNvSpPr>
-            <a:spLocks noGrp="1"/>
-          </p:cNvSpPr>
-          <p:nvPr>
-            <p:ph type="body" idx="1"/>
-          </p:nvPr>
-        </p:nvSpPr>
-        <p:spPr/>
-        <p:txBody>
-          <a:bodyPr/>
-          <a:lstStyle/>
-          <a:p>
-            <a:r>
-              <a:rPr lang="en-US" dirty="0"/>
-              <a:t/>
-            </a:r>
-            <a:endParaRPr lang="en-US" dirty="0"/>
-          </a:p>
-        </p:txBody>
-      </p:sp>
-      <p:sp>
-        <p:nvSpPr>
-          <p:cNvPr id="4" name="Slide Number Placeholder 3"/>
-          <p:cNvSpPr>
-            <a:spLocks noGrp="1"/>
-          </p:cNvSpPr>
-          <p:nvPr>
-            <p:ph type="sldNum" sz="quarter" idx="10"/>
-          </p:nvPr>
-        </p:nvSpPr>
-        <p:spPr/>
-        <p:txBody>
-          <a:bodyPr/>
-          <a:lstStyle/>
-          <a:p>
-            <a:fld id="{F7021451-1387-4CA6-816F-3879F97B5CBC}" type="slidenum">
-              <a:rPr lang="en-US"/>
-              <a:t>15</a:t>
-            </a:fld>
-            <a:endParaRPr lang="en-US"/>
-          </a:p>
-        </p:txBody>
-      </p:sp>
-    </p:spTree>
-    <p:extLst>
-      <p:ext uri="{BB962C8B-B14F-4D97-AF65-F5344CB8AC3E}">
-        <p14:creationId xmlns:p14="http://schemas.microsoft.com/office/powerpoint/2010/main" val="1024086991"/>
-      </p:ext>
-    </p:extLst>
-  </p:cSld>
-  <p:clrMapOvr>
-    <a:masterClrMapping/>
-  </p:clrMapOvr>
-</p:notes>
-</file>
-
-<file path=ppt/notesSlides/notesSlide16.xml><?xml version="1.0" encoding="utf-8"?>
-<p:notes xmlns:a="http://schemas.openxmlformats.org/drawingml/2006/main" xmlns:r="http://schemas.openxmlformats.org/officeDocument/2006/relationships" xmlns:p="http://schemas.openxmlformats.org/presentationml/2006/main">
-  <p:cSld>
-    <p:spTree>
-      <p:nvGrpSpPr>
-        <p:cNvPr id="1" name=""/>
-        <p:cNvGrpSpPr/>
-        <p:nvPr/>
-      </p:nvGrpSpPr>
-      <p:grpSpPr>
-        <a:xfrm>
-          <a:off x="0" y="0"/>
-          <a:ext cx="0" cy="0"/>
-          <a:chOff x="0" y="0"/>
-          <a:chExt cx="0" cy="0"/>
-        </a:xfrm>
-      </p:grpSpPr>
-      <p:sp>
-        <p:nvSpPr>
-          <p:cNvPr id="2" name="Slide Image Placeholder 1"/>
-          <p:cNvSpPr>
-            <a:spLocks noGrp="1" noRot="1" noChangeAspect="1"/>
-          </p:cNvSpPr>
-          <p:nvPr>
-            <p:ph type="sldImg"/>
-          </p:nvPr>
-        </p:nvSpPr>
-        <p:spPr/>
-      </p:sp>
-      <p:sp>
-        <p:nvSpPr>
-          <p:cNvPr id="3" name="Notes Placeholder 2"/>
-          <p:cNvSpPr>
-            <a:spLocks noGrp="1"/>
-          </p:cNvSpPr>
-          <p:nvPr>
-            <p:ph type="body" idx="1"/>
-          </p:nvPr>
-        </p:nvSpPr>
-        <p:spPr/>
-        <p:txBody>
-          <a:bodyPr/>
-          <a:lstStyle/>
-          <a:p>
-            <a:r>
-              <a:rPr lang="en-US" dirty="0"/>
-              <a:t/>
-            </a:r>
-            <a:endParaRPr lang="en-US" dirty="0"/>
-          </a:p>
-        </p:txBody>
-      </p:sp>
-      <p:sp>
-        <p:nvSpPr>
-          <p:cNvPr id="4" name="Slide Number Placeholder 3"/>
-          <p:cNvSpPr>
-            <a:spLocks noGrp="1"/>
-          </p:cNvSpPr>
-          <p:nvPr>
-            <p:ph type="sldNum" sz="quarter" idx="10"/>
-          </p:nvPr>
-        </p:nvSpPr>
-        <p:spPr/>
-        <p:txBody>
-          <a:bodyPr/>
-          <a:lstStyle/>
-          <a:p>
-            <a:fld id="{F7021451-1387-4CA6-816F-3879F97B5CBC}" type="slidenum">
-              <a:rPr lang="en-US"/>
-              <a:t>16</a:t>
-            </a:fld>
-            <a:endParaRPr lang="en-US"/>
-          </a:p>
-        </p:txBody>
-      </p:sp>
-    </p:spTree>
-    <p:extLst>
-      <p:ext uri="{BB962C8B-B14F-4D97-AF65-F5344CB8AC3E}">
-        <p14:creationId xmlns:p14="http://schemas.microsoft.com/office/powerpoint/2010/main" val="1024086991"/>
-      </p:ext>
-    </p:extLst>
-  </p:cSld>
-  <p:clrMapOvr>
-    <a:masterClrMapping/>
-  </p:clrMapOvr>
-</p:notes>
-</file>
-
 <file path=ppt/notesSlides/notesSlide2.xml><?xml version="1.0" encoding="utf-8"?>
 <p:notes xmlns:a="http://schemas.openxmlformats.org/drawingml/2006/main" xmlns:r="http://schemas.openxmlformats.org/officeDocument/2006/relationships" xmlns:p="http://schemas.openxmlformats.org/presentationml/2006/main">
   <p:cSld>
@@ -1221,7 +690,10 @@
           <a:p>
             <a:r>
               <a:rPr lang="en-US" dirty="0"/>
-              <a:t/>
+              <a:t>Purpose: Background — Part 2
+Key argument: What is known and the gap
+Transition: Next slide covers How the research was conducted
+Suggested duration: ~6s</a:t>
             </a:r>
             <a:endParaRPr lang="en-US" dirty="0"/>
           </a:p>
@@ -1397,7 +869,10 @@
           <a:p>
             <a:r>
               <a:rPr lang="en-US" dirty="0"/>
-              <a:t/>
+              <a:t>Purpose: Methodology — Part 1
+Key argument: How the research was conducted
+Transition: Next slide covers How the research was conducted
+Suggested duration: ~6s</a:t>
             </a:r>
             <a:endParaRPr lang="en-US" dirty="0"/>
           </a:p>
@@ -1485,7 +960,10 @@
           <a:p>
             <a:r>
               <a:rPr lang="en-US" dirty="0"/>
-              <a:t/>
+              <a:t>Purpose: Methodology — Part 2
+Key argument: How the research was conducted
+Transition: Next slide covers What the data shows
+Suggested duration: ~6s</a:t>
             </a:r>
             <a:endParaRPr lang="en-US" dirty="0"/>
           </a:p>
@@ -1661,7 +1139,10 @@
           <a:p>
             <a:r>
               <a:rPr lang="en-US" dirty="0"/>
-              <a:t/>
+              <a:t>Purpose: Results — Part 1
+Key argument: What the data shows
+Transition: Next slide covers What results mean for the field
+Suggested duration: ~6s</a:t>
             </a:r>
             <a:endParaRPr lang="en-US" dirty="0"/>
           </a:p>
@@ -1837,7 +1318,10 @@
           <a:p>
             <a:r>
               <a:rPr lang="en-US" dirty="0"/>
-              <a:t/>
+              <a:t>Purpose: Discussion — Part 1
+Key argument: What results mean for the field
+Transition: Next slide covers Summary and contact information
+Suggested duration: ~6s</a:t>
             </a:r>
             <a:endParaRPr lang="en-US" dirty="0"/>
           </a:p>
@@ -2277,9 +1761,45 @@
                   <a:srgbClr val="1A1A1A"/>
                 </a:solidFill>
               </a:rPr>
-              <a:t>What is known and the gap</a:t>
+              <a:t>Project Phoenix is a next-generation distributed system designed to handle high-throughput event processing with guar...</a:t>
             </a:r>
             <a:endParaRPr lang="en-US" sz="1500" dirty="0"/>
+          </a:p>
+        </p:txBody>
+      </p:sp>
+      <p:sp>
+        <p:nvSpPr>
+          <p:cNvPr id="5" name="Text 2"/>
+          <p:cNvSpPr/>
+          <p:nvPr/>
+        </p:nvSpPr>
+        <p:spPr>
+          <a:xfrm>
+            <a:off x="457200" y="6400800"/>
+            <a:ext cx="7620000" cy="274320"/>
+          </a:xfrm>
+          <a:prstGeom prst="rect">
+            <a:avLst/>
+          </a:prstGeom>
+          <a:noFill/>
+          <a:ln/>
+        </p:spPr>
+        <p:txBody>
+          <a:bodyPr wrap="square" rtlCol="0" anchor="ctr"/>
+          <a:lstStyle/>
+          <a:p>
+            <a:pPr algn="l" indent="0" marL="0">
+              <a:buNone/>
+            </a:pPr>
+            <a:r>
+              <a:rPr lang="en-US" sz="800" dirty="0">
+                <a:solidFill>
+                  <a:srgbClr val="9CA3AF"/>
+                </a:solidFill>
+              </a:rPr>
+              <a:t>para-000, para-001</a:t>
+            </a:r>
+            <a:endParaRPr lang="en-US" sz="800" dirty="0"/>
           </a:p>
         </p:txBody>
       </p:sp>
@@ -2323,599 +1843,6 @@
         </p:nvSpPr>
         <p:spPr>
           <a:xfrm>
-            <a:off x="457200" y="274320"/>
-            <a:ext cx="9144000" cy="731520"/>
-          </a:xfrm>
-          <a:prstGeom prst="rect">
-            <a:avLst/>
-          </a:prstGeom>
-          <a:noFill/>
-          <a:ln/>
-        </p:spPr>
-        <p:txBody>
-          <a:bodyPr wrap="square" rtlCol="0" anchor="ctr"/>
-          <a:lstStyle/>
-          <a:p>
-            <a:pPr indent="0" marL="0">
-              <a:buNone/>
-            </a:pPr>
-            <a:r>
-              <a:rPr lang="en-US" sz="2200" b="1" dirty="0">
-                <a:solidFill>
-                  <a:srgbClr val="1A1A1A"/>
-                </a:solidFill>
-              </a:rPr>
-              <a:t>What the data shows</a:t>
-            </a:r>
-            <a:endParaRPr lang="en-US" sz="2200" dirty="0"/>
-          </a:p>
-        </p:txBody>
-      </p:sp>
-      <p:sp>
-        <p:nvSpPr>
-          <p:cNvPr id="3" name="Text 1"/>
-          <p:cNvSpPr/>
-          <p:nvPr/>
-        </p:nvSpPr>
-        <p:spPr>
-          <a:xfrm>
-            <a:off x="457200" y="1097280"/>
-            <a:ext cx="9144000" cy="5029200"/>
-          </a:xfrm>
-          <a:prstGeom prst="rect">
-            <a:avLst/>
-          </a:prstGeom>
-          <a:noFill/>
-          <a:ln/>
-        </p:spPr>
-        <p:txBody>
-          <a:bodyPr wrap="square" rtlCol="0" anchor="ctr"/>
-          <a:lstStyle/>
-          <a:p>
-            <a:pPr marL="342900" indent="-342900">
-              <a:buSzPct val="100000"/>
-              <a:buChar char="•"/>
-            </a:pPr>
-            <a:r>
-              <a:rPr lang="en-US" sz="1400" dirty="0">
-                <a:solidFill>
-                  <a:srgbClr val="1A1A1A"/>
-                </a:solidFill>
-              </a:rPr>
-              <a:t>What the data shows</a:t>
-            </a:r>
-            <a:endParaRPr lang="en-US" sz="1400" dirty="0"/>
-          </a:p>
-        </p:txBody>
-      </p:sp>
-    </p:spTree>
-  </p:cSld>
-  <p:clrMapOvr>
-    <a:masterClrMapping/>
-  </p:clrMapOvr>
-</p:sld>
-</file>
-
-<file path=ppt/slides/slide11.xml><?xml version="1.0" encoding="utf-8"?>
-<p:sld xmlns:a="http://schemas.openxmlformats.org/drawingml/2006/main" xmlns:r="http://schemas.openxmlformats.org/officeDocument/2006/relationships" xmlns:p="http://schemas.openxmlformats.org/presentationml/2006/main">
-  <p:cSld name="Slide 11">
-    <p:bg>
-      <p:bgPr>
-        <a:solidFill>
-          <a:srgbClr val="FFFFFF"/>
-        </a:solidFill>
-      </p:bgPr>
-    </p:bg>
-    <p:spTree>
-      <p:nvGrpSpPr>
-        <p:cNvPr id="1" name=""/>
-        <p:cNvGrpSpPr/>
-        <p:nvPr/>
-      </p:nvGrpSpPr>
-      <p:grpSpPr>
-        <a:xfrm>
-          <a:off x="0" y="0"/>
-          <a:ext cx="0" cy="0"/>
-          <a:chOff x="0" y="0"/>
-          <a:chExt cx="0" cy="0"/>
-        </a:xfrm>
-      </p:grpSpPr>
-      <p:sp>
-        <p:nvSpPr>
-          <p:cNvPr id="2" name="Text 0"/>
-          <p:cNvSpPr/>
-          <p:nvPr/>
-        </p:nvSpPr>
-        <p:spPr>
-          <a:xfrm>
-            <a:off x="457200" y="274320"/>
-            <a:ext cx="9144000" cy="731520"/>
-          </a:xfrm>
-          <a:prstGeom prst="rect">
-            <a:avLst/>
-          </a:prstGeom>
-          <a:noFill/>
-          <a:ln/>
-        </p:spPr>
-        <p:txBody>
-          <a:bodyPr wrap="square" rtlCol="0" anchor="ctr"/>
-          <a:lstStyle/>
-          <a:p>
-            <a:pPr indent="0" marL="0">
-              <a:buNone/>
-            </a:pPr>
-            <a:r>
-              <a:rPr lang="en-US" sz="2200" b="1" dirty="0">
-                <a:solidFill>
-                  <a:srgbClr val="1A1A1A"/>
-                </a:solidFill>
-              </a:rPr>
-              <a:t>What the data shows</a:t>
-            </a:r>
-            <a:endParaRPr lang="en-US" sz="2200" dirty="0"/>
-          </a:p>
-        </p:txBody>
-      </p:sp>
-      <p:sp>
-        <p:nvSpPr>
-          <p:cNvPr id="3" name="Text 1"/>
-          <p:cNvSpPr/>
-          <p:nvPr/>
-        </p:nvSpPr>
-        <p:spPr>
-          <a:xfrm>
-            <a:off x="457200" y="1097280"/>
-            <a:ext cx="9144000" cy="5029200"/>
-          </a:xfrm>
-          <a:prstGeom prst="rect">
-            <a:avLst/>
-          </a:prstGeom>
-          <a:noFill/>
-          <a:ln/>
-        </p:spPr>
-        <p:txBody>
-          <a:bodyPr wrap="square" rtlCol="0" anchor="ctr"/>
-          <a:lstStyle/>
-          <a:p>
-            <a:pPr marL="342900" indent="-342900">
-              <a:buSzPct val="100000"/>
-              <a:buChar char="•"/>
-            </a:pPr>
-            <a:r>
-              <a:rPr lang="en-US" sz="1400" dirty="0">
-                <a:solidFill>
-                  <a:srgbClr val="1A1A1A"/>
-                </a:solidFill>
-              </a:rPr>
-              <a:t>What the data shows</a:t>
-            </a:r>
-            <a:endParaRPr lang="en-US" sz="1400" dirty="0"/>
-          </a:p>
-        </p:txBody>
-      </p:sp>
-    </p:spTree>
-  </p:cSld>
-  <p:clrMapOvr>
-    <a:masterClrMapping/>
-  </p:clrMapOvr>
-</p:sld>
-</file>
-
-<file path=ppt/slides/slide12.xml><?xml version="1.0" encoding="utf-8"?>
-<p:sld xmlns:a="http://schemas.openxmlformats.org/drawingml/2006/main" xmlns:r="http://schemas.openxmlformats.org/officeDocument/2006/relationships" xmlns:p="http://schemas.openxmlformats.org/presentationml/2006/main">
-  <p:cSld name="Slide 12">
-    <p:bg>
-      <p:bgPr>
-        <a:solidFill>
-          <a:srgbClr val="FFFFFF"/>
-        </a:solidFill>
-      </p:bgPr>
-    </p:bg>
-    <p:spTree>
-      <p:nvGrpSpPr>
-        <p:cNvPr id="1" name=""/>
-        <p:cNvGrpSpPr/>
-        <p:nvPr/>
-      </p:nvGrpSpPr>
-      <p:grpSpPr>
-        <a:xfrm>
-          <a:off x="0" y="0"/>
-          <a:ext cx="0" cy="0"/>
-          <a:chOff x="0" y="0"/>
-          <a:chExt cx="0" cy="0"/>
-        </a:xfrm>
-      </p:grpSpPr>
-      <p:sp>
-        <p:nvSpPr>
-          <p:cNvPr id="2" name="Text 0"/>
-          <p:cNvSpPr/>
-          <p:nvPr/>
-        </p:nvSpPr>
-        <p:spPr>
-          <a:xfrm>
-            <a:off x="914400" y="2286000"/>
-            <a:ext cx="7620000" cy="1828800"/>
-          </a:xfrm>
-          <a:prstGeom prst="rect">
-            <a:avLst/>
-          </a:prstGeom>
-          <a:noFill/>
-          <a:ln/>
-        </p:spPr>
-        <p:txBody>
-          <a:bodyPr wrap="square" rtlCol="0" anchor="ctr"/>
-          <a:lstStyle/>
-          <a:p>
-            <a:pPr algn="ctr" indent="0" marL="0">
-              <a:buNone/>
-            </a:pPr>
-            <a:r>
-              <a:rPr lang="en-US" sz="3600" b="1" dirty="0">
-                <a:solidFill>
-                  <a:srgbClr val="1A1A1A"/>
-                </a:solidFill>
-              </a:rPr>
-              <a:t>Discussion</a:t>
-            </a:r>
-            <a:endParaRPr lang="en-US" sz="3600" dirty="0"/>
-          </a:p>
-        </p:txBody>
-      </p:sp>
-    </p:spTree>
-  </p:cSld>
-  <p:clrMapOvr>
-    <a:masterClrMapping/>
-  </p:clrMapOvr>
-</p:sld>
-</file>
-
-<file path=ppt/slides/slide13.xml><?xml version="1.0" encoding="utf-8"?>
-<p:sld xmlns:a="http://schemas.openxmlformats.org/drawingml/2006/main" xmlns:r="http://schemas.openxmlformats.org/officeDocument/2006/relationships" xmlns:p="http://schemas.openxmlformats.org/presentationml/2006/main">
-  <p:cSld name="Slide 13">
-    <p:bg>
-      <p:bgPr>
-        <a:solidFill>
-          <a:srgbClr val="FFFFFF"/>
-        </a:solidFill>
-      </p:bgPr>
-    </p:bg>
-    <p:spTree>
-      <p:nvGrpSpPr>
-        <p:cNvPr id="1" name=""/>
-        <p:cNvGrpSpPr/>
-        <p:nvPr/>
-      </p:nvGrpSpPr>
-      <p:grpSpPr>
-        <a:xfrm>
-          <a:off x="0" y="0"/>
-          <a:ext cx="0" cy="0"/>
-          <a:chOff x="0" y="0"/>
-          <a:chExt cx="0" cy="0"/>
-        </a:xfrm>
-      </p:grpSpPr>
-      <p:sp>
-        <p:nvSpPr>
-          <p:cNvPr id="2" name="Text 0"/>
-          <p:cNvSpPr/>
-          <p:nvPr/>
-        </p:nvSpPr>
-        <p:spPr>
-          <a:xfrm>
-            <a:off x="457200" y="274320"/>
-            <a:ext cx="7620000" cy="731520"/>
-          </a:xfrm>
-          <a:prstGeom prst="rect">
-            <a:avLst/>
-          </a:prstGeom>
-          <a:noFill/>
-          <a:ln/>
-        </p:spPr>
-        <p:txBody>
-          <a:bodyPr wrap="square" rtlCol="0" anchor="ctr"/>
-          <a:lstStyle/>
-          <a:p>
-            <a:pPr indent="0" marL="0">
-              <a:buNone/>
-            </a:pPr>
-            <a:r>
-              <a:rPr lang="en-US" sz="2400" b="1" dirty="0">
-                <a:solidFill>
-                  <a:srgbClr val="1A1A1A"/>
-                </a:solidFill>
-              </a:rPr>
-              <a:t>What results mean for the field</a:t>
-            </a:r>
-            <a:endParaRPr lang="en-US" sz="2400" dirty="0"/>
-          </a:p>
-        </p:txBody>
-      </p:sp>
-      <p:sp>
-        <p:nvSpPr>
-          <p:cNvPr id="3" name="Text 1"/>
-          <p:cNvSpPr/>
-          <p:nvPr/>
-        </p:nvSpPr>
-        <p:spPr>
-          <a:xfrm>
-            <a:off x="457200" y="1097280"/>
-            <a:ext cx="7620000" cy="5029200"/>
-          </a:xfrm>
-          <a:prstGeom prst="rect">
-            <a:avLst/>
-          </a:prstGeom>
-          <a:noFill/>
-          <a:ln/>
-        </p:spPr>
-        <p:txBody>
-          <a:bodyPr wrap="square" rtlCol="0" anchor="ctr"/>
-          <a:lstStyle/>
-          <a:p>
-            <a:pPr marL="342900" indent="-342900">
-              <a:buSzPct val="100000"/>
-              <a:buChar char="•"/>
-            </a:pPr>
-            <a:r>
-              <a:rPr lang="en-US" sz="1500" dirty="0">
-                <a:solidFill>
-                  <a:srgbClr val="1A1A1A"/>
-                </a:solidFill>
-              </a:rPr>
-              <a:t>What results mean for the field</a:t>
-            </a:r>
-            <a:endParaRPr lang="en-US" sz="1500" dirty="0"/>
-          </a:p>
-        </p:txBody>
-      </p:sp>
-    </p:spTree>
-  </p:cSld>
-  <p:clrMapOvr>
-    <a:masterClrMapping/>
-  </p:clrMapOvr>
-</p:sld>
-</file>
-
-<file path=ppt/slides/slide14.xml><?xml version="1.0" encoding="utf-8"?>
-<p:sld xmlns:a="http://schemas.openxmlformats.org/drawingml/2006/main" xmlns:r="http://schemas.openxmlformats.org/officeDocument/2006/relationships" xmlns:p="http://schemas.openxmlformats.org/presentationml/2006/main">
-  <p:cSld name="Slide 14">
-    <p:bg>
-      <p:bgPr>
-        <a:solidFill>
-          <a:srgbClr val="FFFFFF"/>
-        </a:solidFill>
-      </p:bgPr>
-    </p:bg>
-    <p:spTree>
-      <p:nvGrpSpPr>
-        <p:cNvPr id="1" name=""/>
-        <p:cNvGrpSpPr/>
-        <p:nvPr/>
-      </p:nvGrpSpPr>
-      <p:grpSpPr>
-        <a:xfrm>
-          <a:off x="0" y="0"/>
-          <a:ext cx="0" cy="0"/>
-          <a:chOff x="0" y="0"/>
-          <a:chExt cx="0" cy="0"/>
-        </a:xfrm>
-      </p:grpSpPr>
-      <p:sp>
-        <p:nvSpPr>
-          <p:cNvPr id="2" name="Text 0"/>
-          <p:cNvSpPr/>
-          <p:nvPr/>
-        </p:nvSpPr>
-        <p:spPr>
-          <a:xfrm>
-            <a:off x="457200" y="274320"/>
-            <a:ext cx="7620000" cy="731520"/>
-          </a:xfrm>
-          <a:prstGeom prst="rect">
-            <a:avLst/>
-          </a:prstGeom>
-          <a:noFill/>
-          <a:ln/>
-        </p:spPr>
-        <p:txBody>
-          <a:bodyPr wrap="square" rtlCol="0" anchor="ctr"/>
-          <a:lstStyle/>
-          <a:p>
-            <a:pPr indent="0" marL="0">
-              <a:buNone/>
-            </a:pPr>
-            <a:r>
-              <a:rPr lang="en-US" sz="2400" b="1" dirty="0">
-                <a:solidFill>
-                  <a:srgbClr val="1A1A1A"/>
-                </a:solidFill>
-              </a:rPr>
-              <a:t>What results mean for the field</a:t>
-            </a:r>
-            <a:endParaRPr lang="en-US" sz="2400" dirty="0"/>
-          </a:p>
-        </p:txBody>
-      </p:sp>
-      <p:sp>
-        <p:nvSpPr>
-          <p:cNvPr id="3" name="Text 1"/>
-          <p:cNvSpPr/>
-          <p:nvPr/>
-        </p:nvSpPr>
-        <p:spPr>
-          <a:xfrm>
-            <a:off x="457200" y="1097280"/>
-            <a:ext cx="7620000" cy="5029200"/>
-          </a:xfrm>
-          <a:prstGeom prst="rect">
-            <a:avLst/>
-          </a:prstGeom>
-          <a:noFill/>
-          <a:ln/>
-        </p:spPr>
-        <p:txBody>
-          <a:bodyPr wrap="square" rtlCol="0" anchor="ctr"/>
-          <a:lstStyle/>
-          <a:p>
-            <a:pPr marL="342900" indent="-342900">
-              <a:buSzPct val="100000"/>
-              <a:buChar char="•"/>
-            </a:pPr>
-            <a:r>
-              <a:rPr lang="en-US" sz="1500" dirty="0">
-                <a:solidFill>
-                  <a:srgbClr val="1A1A1A"/>
-                </a:solidFill>
-              </a:rPr>
-              <a:t>What results mean for the field</a:t>
-            </a:r>
-            <a:endParaRPr lang="en-US" sz="1500" dirty="0"/>
-          </a:p>
-        </p:txBody>
-      </p:sp>
-    </p:spTree>
-  </p:cSld>
-  <p:clrMapOvr>
-    <a:masterClrMapping/>
-  </p:clrMapOvr>
-</p:sld>
-</file>
-
-<file path=ppt/slides/slide15.xml><?xml version="1.0" encoding="utf-8"?>
-<p:sld xmlns:a="http://schemas.openxmlformats.org/drawingml/2006/main" xmlns:r="http://schemas.openxmlformats.org/officeDocument/2006/relationships" xmlns:p="http://schemas.openxmlformats.org/presentationml/2006/main">
-  <p:cSld name="Slide 15">
-    <p:bg>
-      <p:bgPr>
-        <a:solidFill>
-          <a:srgbClr val="FFFFFF"/>
-        </a:solidFill>
-      </p:bgPr>
-    </p:bg>
-    <p:spTree>
-      <p:nvGrpSpPr>
-        <p:cNvPr id="1" name=""/>
-        <p:cNvGrpSpPr/>
-        <p:nvPr/>
-      </p:nvGrpSpPr>
-      <p:grpSpPr>
-        <a:xfrm>
-          <a:off x="0" y="0"/>
-          <a:ext cx="0" cy="0"/>
-          <a:chOff x="0" y="0"/>
-          <a:chExt cx="0" cy="0"/>
-        </a:xfrm>
-      </p:grpSpPr>
-      <p:sp>
-        <p:nvSpPr>
-          <p:cNvPr id="2" name="Text 0"/>
-          <p:cNvSpPr/>
-          <p:nvPr/>
-        </p:nvSpPr>
-        <p:spPr>
-          <a:xfrm>
-            <a:off x="457200" y="274320"/>
-            <a:ext cx="7620000" cy="731520"/>
-          </a:xfrm>
-          <a:prstGeom prst="rect">
-            <a:avLst/>
-          </a:prstGeom>
-          <a:noFill/>
-          <a:ln/>
-        </p:spPr>
-        <p:txBody>
-          <a:bodyPr wrap="square" rtlCol="0" anchor="ctr"/>
-          <a:lstStyle/>
-          <a:p>
-            <a:pPr indent="0" marL="0">
-              <a:buNone/>
-            </a:pPr>
-            <a:r>
-              <a:rPr lang="en-US" sz="2400" b="1" dirty="0">
-                <a:solidFill>
-                  <a:srgbClr val="1A1A1A"/>
-                </a:solidFill>
-              </a:rPr>
-              <a:t>What results mean for the field</a:t>
-            </a:r>
-            <a:endParaRPr lang="en-US" sz="2400" dirty="0"/>
-          </a:p>
-        </p:txBody>
-      </p:sp>
-      <p:sp>
-        <p:nvSpPr>
-          <p:cNvPr id="3" name="Text 1"/>
-          <p:cNvSpPr/>
-          <p:nvPr/>
-        </p:nvSpPr>
-        <p:spPr>
-          <a:xfrm>
-            <a:off x="457200" y="1097280"/>
-            <a:ext cx="7620000" cy="5029200"/>
-          </a:xfrm>
-          <a:prstGeom prst="rect">
-            <a:avLst/>
-          </a:prstGeom>
-          <a:noFill/>
-          <a:ln/>
-        </p:spPr>
-        <p:txBody>
-          <a:bodyPr wrap="square" rtlCol="0" anchor="ctr"/>
-          <a:lstStyle/>
-          <a:p>
-            <a:pPr marL="342900" indent="-342900">
-              <a:buSzPct val="100000"/>
-              <a:buChar char="•"/>
-            </a:pPr>
-            <a:r>
-              <a:rPr lang="en-US" sz="1500" dirty="0">
-                <a:solidFill>
-                  <a:srgbClr val="1A1A1A"/>
-                </a:solidFill>
-              </a:rPr>
-              <a:t>What results mean for the field</a:t>
-            </a:r>
-            <a:endParaRPr lang="en-US" sz="1500" dirty="0"/>
-          </a:p>
-        </p:txBody>
-      </p:sp>
-    </p:spTree>
-  </p:cSld>
-  <p:clrMapOvr>
-    <a:masterClrMapping/>
-  </p:clrMapOvr>
-</p:sld>
-</file>
-
-<file path=ppt/slides/slide16.xml><?xml version="1.0" encoding="utf-8"?>
-<p:sld xmlns:a="http://schemas.openxmlformats.org/drawingml/2006/main" xmlns:r="http://schemas.openxmlformats.org/officeDocument/2006/relationships" xmlns:p="http://schemas.openxmlformats.org/presentationml/2006/main">
-  <p:cSld name="Slide 16">
-    <p:bg>
-      <p:bgPr>
-        <a:solidFill>
-          <a:srgbClr val="FFFFFF"/>
-        </a:solidFill>
-      </p:bgPr>
-    </p:bg>
-    <p:spTree>
-      <p:nvGrpSpPr>
-        <p:cNvPr id="1" name=""/>
-        <p:cNvGrpSpPr/>
-        <p:nvPr/>
-      </p:nvGrpSpPr>
-      <p:grpSpPr>
-        <a:xfrm>
-          <a:off x="0" y="0"/>
-          <a:ext cx="0" cy="0"/>
-          <a:chOff x="0" y="0"/>
-          <a:chExt cx="0" cy="0"/>
-        </a:xfrm>
-      </p:grpSpPr>
-      <p:sp>
-        <p:nvSpPr>
-          <p:cNvPr id="2" name="Text 0"/>
-          <p:cNvSpPr/>
-          <p:nvPr/>
-        </p:nvSpPr>
-        <p:spPr>
-          <a:xfrm>
             <a:off x="914400" y="2286000"/>
             <a:ext cx="7620000" cy="1371600"/>
           </a:xfrm>
@@ -3079,9 +2006,45 @@
                   <a:srgbClr val="1A1A1A"/>
                 </a:solidFill>
               </a:rPr>
-              <a:t>What is known and the gap</a:t>
+              <a:t>Our existing monolithic architecture faces several critical limitations:</a:t>
             </a:r>
             <a:endParaRPr lang="en-US" sz="1500" dirty="0"/>
+          </a:p>
+        </p:txBody>
+      </p:sp>
+      <p:sp>
+        <p:nvSpPr>
+          <p:cNvPr id="5" name="Text 2"/>
+          <p:cNvSpPr/>
+          <p:nvPr/>
+        </p:nvSpPr>
+        <p:spPr>
+          <a:xfrm>
+            <a:off x="457200" y="6400800"/>
+            <a:ext cx="7620000" cy="274320"/>
+          </a:xfrm>
+          <a:prstGeom prst="rect">
+            <a:avLst/>
+          </a:prstGeom>
+          <a:noFill/>
+          <a:ln/>
+        </p:spPr>
+        <p:txBody>
+          <a:bodyPr wrap="square" rtlCol="0" anchor="ctr"/>
+          <a:lstStyle/>
+          <a:p>
+            <a:pPr algn="l" indent="0" marL="0">
+              <a:buNone/>
+            </a:pPr>
+            <a:r>
+              <a:rPr lang="en-US" sz="800" dirty="0">
+                <a:solidFill>
+                  <a:srgbClr val="9CA3AF"/>
+                </a:solidFill>
+              </a:rPr>
+              <a:t>para-000, para-001</a:t>
+            </a:r>
+            <a:endParaRPr lang="en-US" sz="800" dirty="0"/>
           </a:p>
         </p:txBody>
       </p:sp>
@@ -3125,8 +2088,8 @@
         </p:nvSpPr>
         <p:spPr>
           <a:xfrm>
-            <a:off x="457200" y="274320"/>
-            <a:ext cx="7620000" cy="731520"/>
+            <a:off x="914400" y="2286000"/>
+            <a:ext cx="7620000" cy="1828800"/>
           </a:xfrm>
           <a:prstGeom prst="rect">
             <a:avLst/>
@@ -3138,18 +2101,18 @@
           <a:bodyPr wrap="square" rtlCol="0" anchor="ctr"/>
           <a:lstStyle/>
           <a:p>
-            <a:pPr indent="0" marL="0">
+            <a:pPr algn="ctr" indent="0" marL="0">
               <a:buNone/>
             </a:pPr>
             <a:r>
-              <a:rPr lang="en-US" sz="2400" b="1" dirty="0">
+              <a:rPr lang="en-US" sz="3600" b="1" dirty="0">
                 <a:solidFill>
                   <a:srgbClr val="1A1A1A"/>
                 </a:solidFill>
               </a:rPr>
-              <a:t>What is known and the gap</a:t>
-            </a:r>
-            <a:endParaRPr lang="en-US" sz="2400" dirty="0"/>
+              <a:t>Methodology</a:t>
+            </a:r>
+            <a:endParaRPr lang="en-US" sz="3600" dirty="0"/>
           </a:p>
         </p:txBody>
       </p:sp>
@@ -3161,8 +2124,8 @@
         </p:nvSpPr>
         <p:spPr>
           <a:xfrm>
-            <a:off x="457200" y="1097280"/>
-            <a:ext cx="7620000" cy="5029200"/>
+            <a:off x="457200" y="6400800"/>
+            <a:ext cx="7620000" cy="274320"/>
           </a:xfrm>
           <a:prstGeom prst="rect">
             <a:avLst/>
@@ -3174,19 +2137,18 @@
           <a:bodyPr wrap="square" rtlCol="0" anchor="ctr"/>
           <a:lstStyle/>
           <a:p>
-            <a:pPr marL="342900" indent="-342900">
-              <a:buSzPct val="100000"/>
-              <a:buChar char="•"/>
+            <a:pPr algn="l" indent="0" marL="0">
+              <a:buNone/>
             </a:pPr>
             <a:r>
-              <a:rPr lang="en-US" sz="1500" dirty="0">
+              <a:rPr lang="en-US" sz="800" dirty="0">
                 <a:solidFill>
-                  <a:srgbClr val="1A1A1A"/>
+                  <a:srgbClr val="9CA3AF"/>
                 </a:solidFill>
               </a:rPr>
-              <a:t>What is known and the gap</a:t>
-            </a:r>
-            <a:endParaRPr lang="en-US" sz="1500" dirty="0"/>
+              <a:t>para-002, para-003</a:t>
+            </a:r>
+            <a:endParaRPr lang="en-US" sz="800" dirty="0"/>
           </a:p>
         </p:txBody>
       </p:sp>
@@ -3230,8 +2192,8 @@
         </p:nvSpPr>
         <p:spPr>
           <a:xfrm>
-            <a:off x="914400" y="2286000"/>
-            <a:ext cx="7620000" cy="1828800"/>
+            <a:off x="457200" y="274320"/>
+            <a:ext cx="7620000" cy="731520"/>
           </a:xfrm>
           <a:prstGeom prst="rect">
             <a:avLst/>
@@ -3243,18 +2205,91 @@
           <a:bodyPr wrap="square" rtlCol="0" anchor="ctr"/>
           <a:lstStyle/>
           <a:p>
-            <a:pPr algn="ctr" indent="0" marL="0">
+            <a:pPr indent="0" marL="0">
               <a:buNone/>
             </a:pPr>
             <a:r>
-              <a:rPr lang="en-US" sz="3600" b="1" dirty="0">
+              <a:rPr lang="en-US" sz="1800" b="1" dirty="0">
                 <a:solidFill>
                   <a:srgbClr val="1A1A1A"/>
                 </a:solidFill>
               </a:rPr>
-              <a:t>Methodology</a:t>
-            </a:r>
-            <a:endParaRPr lang="en-US" sz="3600" dirty="0"/>
+              <a:t>How the research was conducted</a:t>
+            </a:r>
+            <a:endParaRPr lang="en-US" sz="1800" dirty="0"/>
+          </a:p>
+        </p:txBody>
+      </p:sp>
+      <p:sp>
+        <p:nvSpPr>
+          <p:cNvPr id="3" name="Text 1"/>
+          <p:cNvSpPr/>
+          <p:nvPr/>
+        </p:nvSpPr>
+        <p:spPr>
+          <a:xfrm>
+            <a:off x="457200" y="1097280"/>
+            <a:ext cx="7620000" cy="5029200"/>
+          </a:xfrm>
+          <a:prstGeom prst="rect">
+            <a:avLst/>
+          </a:prstGeom>
+          <a:noFill/>
+          <a:ln/>
+        </p:spPr>
+        <p:txBody>
+          <a:bodyPr wrap="square" rtlCol="0" anchor="ctr"/>
+          <a:lstStyle/>
+          <a:p>
+            <a:pPr marL="342900" indent="-342900">
+              <a:buSzPct val="100000"/>
+              <a:buChar char="•"/>
+            </a:pPr>
+            <a:r>
+              <a:rPr lang="en-US" sz="1300" dirty="0">
+                <a:solidFill>
+                  <a:srgbClr val="1A1A1A"/>
+                </a:solidFill>
+              </a:rPr>
+              <a:t>We propose decomposing the system into six bounded contexts:</a:t>
+            </a:r>
+            <a:endParaRPr lang="en-US" sz="1300" dirty="0"/>
+          </a:p>
+        </p:txBody>
+      </p:sp>
+      <p:sp>
+        <p:nvSpPr>
+          <p:cNvPr id="5" name="Text 2"/>
+          <p:cNvSpPr/>
+          <p:nvPr/>
+        </p:nvSpPr>
+        <p:spPr>
+          <a:xfrm>
+            <a:off x="457200" y="6400800"/>
+            <a:ext cx="7620000" cy="274320"/>
+          </a:xfrm>
+          <a:prstGeom prst="rect">
+            <a:avLst/>
+          </a:prstGeom>
+          <a:noFill/>
+          <a:ln/>
+        </p:spPr>
+        <p:txBody>
+          <a:bodyPr wrap="square" rtlCol="0" anchor="ctr"/>
+          <a:lstStyle/>
+          <a:p>
+            <a:pPr algn="l" indent="0" marL="0">
+              <a:buNone/>
+            </a:pPr>
+            <a:r>
+              <a:rPr lang="en-US" sz="800" dirty="0">
+                <a:solidFill>
+                  <a:srgbClr val="9CA3AF"/>
+                </a:solidFill>
+              </a:rPr>
+              <a:t>para-002, para-003</a:t>
+            </a:r>
+            <a:endParaRPr lang="en-US" sz="800" dirty="0"/>
           </a:p>
         </p:txBody>
       </p:sp>
@@ -3315,14 +2350,14 @@
               <a:buNone/>
             </a:pPr>
             <a:r>
-              <a:rPr lang="en-US" sz="2400" b="1" dirty="0">
+              <a:rPr lang="en-US" sz="1800" b="1" dirty="0">
                 <a:solidFill>
                   <a:srgbClr val="1A1A1A"/>
                 </a:solidFill>
               </a:rPr>
               <a:t>How the research was conducted</a:t>
             </a:r>
-            <a:endParaRPr lang="en-US" sz="2400" dirty="0"/>
+            <a:endParaRPr lang="en-US" sz="1800" dirty="0"/>
           </a:p>
         </p:txBody>
       </p:sp>
@@ -3352,14 +2387,50 @@
               <a:buChar char="•"/>
             </a:pPr>
             <a:r>
-              <a:rPr lang="en-US" sz="1500" dirty="0">
+              <a:rPr lang="en-US" sz="1300" dirty="0">
                 <a:solidFill>
                   <a:srgbClr val="1A1A1A"/>
                 </a:solidFill>
               </a:rPr>
-              <a:t>How the research was conducted</a:t>
-            </a:r>
-            <a:endParaRPr lang="en-US" sz="1500" dirty="0"/>
+              <a:t>The system follows an event-driven architecture:</a:t>
+            </a:r>
+            <a:endParaRPr lang="en-US" sz="1300" dirty="0"/>
+          </a:p>
+        </p:txBody>
+      </p:sp>
+      <p:sp>
+        <p:nvSpPr>
+          <p:cNvPr id="5" name="Text 2"/>
+          <p:cNvSpPr/>
+          <p:nvPr/>
+        </p:nvSpPr>
+        <p:spPr>
+          <a:xfrm>
+            <a:off x="457200" y="6400800"/>
+            <a:ext cx="7620000" cy="274320"/>
+          </a:xfrm>
+          <a:prstGeom prst="rect">
+            <a:avLst/>
+          </a:prstGeom>
+          <a:noFill/>
+          <a:ln/>
+        </p:spPr>
+        <p:txBody>
+          <a:bodyPr wrap="square" rtlCol="0" anchor="ctr"/>
+          <a:lstStyle/>
+          <a:p>
+            <a:pPr algn="l" indent="0" marL="0">
+              <a:buNone/>
+            </a:pPr>
+            <a:r>
+              <a:rPr lang="en-US" sz="800" dirty="0">
+                <a:solidFill>
+                  <a:srgbClr val="9CA3AF"/>
+                </a:solidFill>
+              </a:rPr>
+              <a:t>para-002, para-003</a:t>
+            </a:r>
+            <a:endParaRPr lang="en-US" sz="800" dirty="0"/>
           </a:p>
         </p:txBody>
       </p:sp>
@@ -3403,8 +2474,8 @@
         </p:nvSpPr>
         <p:spPr>
           <a:xfrm>
-            <a:off x="457200" y="274320"/>
-            <a:ext cx="7620000" cy="731520"/>
+            <a:off x="914400" y="2286000"/>
+            <a:ext cx="7620000" cy="1828800"/>
           </a:xfrm>
           <a:prstGeom prst="rect">
             <a:avLst/>
@@ -3416,18 +2487,18 @@
           <a:bodyPr wrap="square" rtlCol="0" anchor="ctr"/>
           <a:lstStyle/>
           <a:p>
-            <a:pPr indent="0" marL="0">
+            <a:pPr algn="ctr" indent="0" marL="0">
               <a:buNone/>
             </a:pPr>
             <a:r>
-              <a:rPr lang="en-US" sz="2400" b="1" dirty="0">
+              <a:rPr lang="en-US" sz="3600" b="1" dirty="0">
                 <a:solidFill>
                   <a:srgbClr val="1A1A1A"/>
                 </a:solidFill>
               </a:rPr>
-              <a:t>How the research was conducted</a:t>
-            </a:r>
-            <a:endParaRPr lang="en-US" sz="2400" dirty="0"/>
+              <a:t>Results</a:t>
+            </a:r>
+            <a:endParaRPr lang="en-US" sz="3600" dirty="0"/>
           </a:p>
         </p:txBody>
       </p:sp>
@@ -3439,8 +2510,8 @@
         </p:nvSpPr>
         <p:spPr>
           <a:xfrm>
-            <a:off x="457200" y="1097280"/>
-            <a:ext cx="7620000" cy="5029200"/>
+            <a:off x="457200" y="6400800"/>
+            <a:ext cx="7620000" cy="274320"/>
           </a:xfrm>
           <a:prstGeom prst="rect">
             <a:avLst/>
@@ -3452,19 +2523,18 @@
           <a:bodyPr wrap="square" rtlCol="0" anchor="ctr"/>
           <a:lstStyle/>
           <a:p>
-            <a:pPr marL="342900" indent="-342900">
-              <a:buSzPct val="100000"/>
-              <a:buChar char="•"/>
+            <a:pPr algn="l" indent="0" marL="0">
+              <a:buNone/>
             </a:pPr>
             <a:r>
-              <a:rPr lang="en-US" sz="1500" dirty="0">
+              <a:rPr lang="en-US" sz="800" dirty="0">
                 <a:solidFill>
-                  <a:srgbClr val="1A1A1A"/>
+                  <a:srgbClr val="9CA3AF"/>
                 </a:solidFill>
               </a:rPr>
-              <a:t>How the research was conducted</a:t>
-            </a:r>
-            <a:endParaRPr lang="en-US" sz="1500" dirty="0"/>
+              <a:t>para-004, para-005</a:t>
+            </a:r>
+            <a:endParaRPr lang="en-US" sz="800" dirty="0"/>
           </a:p>
         </p:txBody>
       </p:sp>
@@ -3509,7 +2579,7 @@
         <p:spPr>
           <a:xfrm>
             <a:off x="457200" y="274320"/>
-            <a:ext cx="7620000" cy="731520"/>
+            <a:ext cx="6858000" cy="731520"/>
           </a:xfrm>
           <a:prstGeom prst="rect">
             <a:avLst/>
@@ -3525,14 +2595,14 @@
               <a:buNone/>
             </a:pPr>
             <a:r>
-              <a:rPr lang="en-US" sz="2400" b="1" dirty="0">
+              <a:rPr lang="en-US" sz="2000" b="1" dirty="0">
                 <a:solidFill>
                   <a:srgbClr val="1A1A1A"/>
                 </a:solidFill>
               </a:rPr>
-              <a:t>How the research was conducted</a:t>
-            </a:r>
-            <a:endParaRPr lang="en-US" sz="2400" dirty="0"/>
+              <a:t>What the data shows</a:t>
+            </a:r>
+            <a:endParaRPr lang="en-US" sz="2000" dirty="0"/>
           </a:p>
         </p:txBody>
       </p:sp>
@@ -3545,7 +2615,7 @@
         <p:spPr>
           <a:xfrm>
             <a:off x="457200" y="1097280"/>
-            <a:ext cx="7620000" cy="5029200"/>
+            <a:ext cx="6858000" cy="5029200"/>
           </a:xfrm>
           <a:prstGeom prst="rect">
             <a:avLst/>
@@ -3562,14 +2632,65 @@
               <a:buChar char="•"/>
             </a:pPr>
             <a:r>
-              <a:rPr lang="en-US" sz="1500" dirty="0">
+              <a:rPr lang="en-US" sz="1400" dirty="0">
                 <a:solidFill>
                   <a:srgbClr val="1A1A1A"/>
                 </a:solidFill>
               </a:rPr>
-              <a:t>How the research was conducted</a:t>
-            </a:r>
-            <a:endParaRPr lang="en-US" sz="1500" dirty="0"/>
+              <a:t>After full implementation, we project:</a:t>
+            </a:r>
+            <a:endParaRPr lang="en-US" sz="1400" dirty="0"/>
+          </a:p>
+          <a:p>
+            <a:pPr marL="342900" indent="-342900">
+              <a:buSzPct val="100000"/>
+              <a:buChar char="•"/>
+            </a:pPr>
+            <a:r>
+              <a:rPr lang="en-US" sz="1400" dirty="0">
+                <a:solidFill>
+                  <a:srgbClr val="1A1A1A"/>
+                </a:solidFill>
+              </a:rPr>
+              <a:t>Project Phoenix represents a fundamental shift from our current reactive architecture to a proactive, event-driven sy...</a:t>
+            </a:r>
+            <a:endParaRPr lang="en-US" sz="1400" dirty="0"/>
+          </a:p>
+        </p:txBody>
+      </p:sp>
+      <p:sp>
+        <p:nvSpPr>
+          <p:cNvPr id="5" name="Text 2"/>
+          <p:cNvSpPr/>
+          <p:nvPr/>
+        </p:nvSpPr>
+        <p:spPr>
+          <a:xfrm>
+            <a:off x="457200" y="6400800"/>
+            <a:ext cx="6858000" cy="274320"/>
+          </a:xfrm>
+          <a:prstGeom prst="rect">
+            <a:avLst/>
+          </a:prstGeom>
+          <a:noFill/>
+          <a:ln/>
+        </p:spPr>
+        <p:txBody>
+          <a:bodyPr wrap="square" rtlCol="0" anchor="ctr"/>
+          <a:lstStyle/>
+          <a:p>
+            <a:pPr algn="l" indent="0" marL="0">
+              <a:buNone/>
+            </a:pPr>
+            <a:r>
+              <a:rPr lang="en-US" sz="800" dirty="0">
+                <a:solidFill>
+                  <a:srgbClr val="9CA3AF"/>
+                </a:solidFill>
+              </a:rPr>
+              <a:t>para-004, para-005</a:t>
+            </a:r>
+            <a:endParaRPr lang="en-US" sz="800" dirty="0"/>
           </a:p>
         </p:txBody>
       </p:sp>
@@ -3635,7 +2756,7 @@
                   <a:srgbClr val="1A1A1A"/>
                 </a:solidFill>
               </a:rPr>
-              <a:t>Results</a:t>
+              <a:t>Discussion</a:t>
             </a:r>
             <a:endParaRPr lang="en-US" sz="3600" dirty="0"/>
           </a:p>
@@ -3682,7 +2803,7 @@
         <p:spPr>
           <a:xfrm>
             <a:off x="457200" y="274320"/>
-            <a:ext cx="9144000" cy="731520"/>
+            <a:ext cx="7620000" cy="731520"/>
           </a:xfrm>
           <a:prstGeom prst="rect">
             <a:avLst/>
@@ -3698,14 +2819,14 @@
               <a:buNone/>
             </a:pPr>
             <a:r>
-              <a:rPr lang="en-US" sz="2200" b="1" dirty="0">
+              <a:rPr lang="en-US" sz="2400" b="1" dirty="0">
                 <a:solidFill>
                   <a:srgbClr val="1A1A1A"/>
                 </a:solidFill>
               </a:rPr>
-              <a:t>What the data shows</a:t>
-            </a:r>
-            <a:endParaRPr lang="en-US" sz="2200" dirty="0"/>
+              <a:t>What results mean for the field</a:t>
+            </a:r>
+            <a:endParaRPr lang="en-US" sz="2400" dirty="0"/>
           </a:p>
         </p:txBody>
       </p:sp>
@@ -3718,7 +2839,7 @@
         <p:spPr>
           <a:xfrm>
             <a:off x="457200" y="1097280"/>
-            <a:ext cx="9144000" cy="5029200"/>
+            <a:ext cx="7620000" cy="5029200"/>
           </a:xfrm>
           <a:prstGeom prst="rect">
             <a:avLst/>
@@ -3735,14 +2856,14 @@
               <a:buChar char="•"/>
             </a:pPr>
             <a:r>
-              <a:rPr lang="en-US" sz="1400" dirty="0">
+              <a:rPr lang="en-US" sz="1500" dirty="0">
                 <a:solidFill>
                   <a:srgbClr val="1A1A1A"/>
                 </a:solidFill>
               </a:rPr>
-              <a:t>What the data shows</a:t>
-            </a:r>
-            <a:endParaRPr lang="en-US" sz="1400" dirty="0"/>
+              <a:t>What results mean for the field</a:t>
+            </a:r>
+            <a:endParaRPr lang="en-US" sz="1500" dirty="0"/>
           </a:p>
         </p:txBody>
       </p:sp>

</xml_diff>

<commit_message>
fix(m12.7.1): harden source propagation, speaker notes, quality gates (#88)
- Fix preserveSourceRefs: keyword-based matching replaces broken exact sectionPath match
- Fix slidespec body: round-robin paragraph distribution across slides in same section
- Fix renderer: slide.addNotes() instead of slide.notes = for pptxgenjs v4
- Fix theme-layout: remove two-column fallback for 2-body-length slides
- Add quality gates: fail on empty title, zero sourceRefs, duplicate title+body, missing notes
- Update pptx-renderer tests: remove executive-summary assertion (fixture has none)
- All 5 test suites pass, npm run check passes
</commit_message>
<xml_diff>
--- a/examples/business-review/e2e-output.pptx
+++ b/examples/business-review/e2e-output.pptx
@@ -15,15 +15,9 @@
     <p:sldId id="263" r:id="rId9"/>
     <p:sldId id="264" r:id="rId10"/>
     <p:sldId id="265" r:id="rId11"/>
-    <p:sldId id="266" r:id="rId12"/>
-    <p:sldId id="267" r:id="rId13"/>
-    <p:sldId id="268" r:id="rId14"/>
-    <p:sldId id="269" r:id="rId15"/>
-    <p:sldId id="270" r:id="rId16"/>
-    <p:sldId id="271" r:id="rId17"/>
   </p:sldIdLst>
   <p:notesMasterIdLst>
-    <p:notesMasterId r:id="rId18"/>
+    <p:notesMasterId r:id="rId12"/>
   </p:notesMasterIdLst>
   <p:sldSz cx="9144000" cy="5143500"/>
   <p:notesSz cx="5143500" cy="9144000"/>
@@ -517,7 +511,10 @@
           <a:p>
             <a:r>
               <a:rPr lang="en-US" dirty="0"/>
-              <a:t/>
+              <a:t>Purpose: Background — Part 1
+Key argument: What is known and the gap
+Transition: Next slide covers What is known and the gap
+Suggested duration: ~6s</a:t>
             </a:r>
             <a:endParaRPr lang="en-US" dirty="0"/>
           </a:p>
@@ -647,534 +644,6 @@
 </p:notes>
 </file>
 
-<file path=ppt/notesSlides/notesSlide11.xml><?xml version="1.0" encoding="utf-8"?>
-<p:notes xmlns:a="http://schemas.openxmlformats.org/drawingml/2006/main" xmlns:r="http://schemas.openxmlformats.org/officeDocument/2006/relationships" xmlns:p="http://schemas.openxmlformats.org/presentationml/2006/main">
-  <p:cSld>
-    <p:spTree>
-      <p:nvGrpSpPr>
-        <p:cNvPr id="1" name=""/>
-        <p:cNvGrpSpPr/>
-        <p:nvPr/>
-      </p:nvGrpSpPr>
-      <p:grpSpPr>
-        <a:xfrm>
-          <a:off x="0" y="0"/>
-          <a:ext cx="0" cy="0"/>
-          <a:chOff x="0" y="0"/>
-          <a:chExt cx="0" cy="0"/>
-        </a:xfrm>
-      </p:grpSpPr>
-      <p:sp>
-        <p:nvSpPr>
-          <p:cNvPr id="2" name="Slide Image Placeholder 1"/>
-          <p:cNvSpPr>
-            <a:spLocks noGrp="1" noRot="1" noChangeAspect="1"/>
-          </p:cNvSpPr>
-          <p:nvPr>
-            <p:ph type="sldImg"/>
-          </p:nvPr>
-        </p:nvSpPr>
-        <p:spPr/>
-      </p:sp>
-      <p:sp>
-        <p:nvSpPr>
-          <p:cNvPr id="3" name="Notes Placeholder 2"/>
-          <p:cNvSpPr>
-            <a:spLocks noGrp="1"/>
-          </p:cNvSpPr>
-          <p:nvPr>
-            <p:ph type="body" idx="1"/>
-          </p:nvPr>
-        </p:nvSpPr>
-        <p:spPr/>
-        <p:txBody>
-          <a:bodyPr/>
-          <a:lstStyle/>
-          <a:p>
-            <a:r>
-              <a:rPr lang="en-US" dirty="0"/>
-              <a:t/>
-            </a:r>
-            <a:endParaRPr lang="en-US" dirty="0"/>
-          </a:p>
-        </p:txBody>
-      </p:sp>
-      <p:sp>
-        <p:nvSpPr>
-          <p:cNvPr id="4" name="Slide Number Placeholder 3"/>
-          <p:cNvSpPr>
-            <a:spLocks noGrp="1"/>
-          </p:cNvSpPr>
-          <p:nvPr>
-            <p:ph type="sldNum" sz="quarter" idx="10"/>
-          </p:nvPr>
-        </p:nvSpPr>
-        <p:spPr/>
-        <p:txBody>
-          <a:bodyPr/>
-          <a:lstStyle/>
-          <a:p>
-            <a:fld id="{F7021451-1387-4CA6-816F-3879F97B5CBC}" type="slidenum">
-              <a:rPr lang="en-US"/>
-              <a:t>11</a:t>
-            </a:fld>
-            <a:endParaRPr lang="en-US"/>
-          </a:p>
-        </p:txBody>
-      </p:sp>
-    </p:spTree>
-    <p:extLst>
-      <p:ext uri="{BB962C8B-B14F-4D97-AF65-F5344CB8AC3E}">
-        <p14:creationId xmlns:p14="http://schemas.microsoft.com/office/powerpoint/2010/main" val="1024086991"/>
-      </p:ext>
-    </p:extLst>
-  </p:cSld>
-  <p:clrMapOvr>
-    <a:masterClrMapping/>
-  </p:clrMapOvr>
-</p:notes>
-</file>
-
-<file path=ppt/notesSlides/notesSlide12.xml><?xml version="1.0" encoding="utf-8"?>
-<p:notes xmlns:a="http://schemas.openxmlformats.org/drawingml/2006/main" xmlns:r="http://schemas.openxmlformats.org/officeDocument/2006/relationships" xmlns:p="http://schemas.openxmlformats.org/presentationml/2006/main">
-  <p:cSld>
-    <p:spTree>
-      <p:nvGrpSpPr>
-        <p:cNvPr id="1" name=""/>
-        <p:cNvGrpSpPr/>
-        <p:nvPr/>
-      </p:nvGrpSpPr>
-      <p:grpSpPr>
-        <a:xfrm>
-          <a:off x="0" y="0"/>
-          <a:ext cx="0" cy="0"/>
-          <a:chOff x="0" y="0"/>
-          <a:chExt cx="0" cy="0"/>
-        </a:xfrm>
-      </p:grpSpPr>
-      <p:sp>
-        <p:nvSpPr>
-          <p:cNvPr id="2" name="Slide Image Placeholder 1"/>
-          <p:cNvSpPr>
-            <a:spLocks noGrp="1" noRot="1" noChangeAspect="1"/>
-          </p:cNvSpPr>
-          <p:nvPr>
-            <p:ph type="sldImg"/>
-          </p:nvPr>
-        </p:nvSpPr>
-        <p:spPr/>
-      </p:sp>
-      <p:sp>
-        <p:nvSpPr>
-          <p:cNvPr id="3" name="Notes Placeholder 2"/>
-          <p:cNvSpPr>
-            <a:spLocks noGrp="1"/>
-          </p:cNvSpPr>
-          <p:nvPr>
-            <p:ph type="body" idx="1"/>
-          </p:nvPr>
-        </p:nvSpPr>
-        <p:spPr/>
-        <p:txBody>
-          <a:bodyPr/>
-          <a:lstStyle/>
-          <a:p>
-            <a:r>
-              <a:rPr lang="en-US" dirty="0"/>
-              <a:t/>
-            </a:r>
-            <a:endParaRPr lang="en-US" dirty="0"/>
-          </a:p>
-        </p:txBody>
-      </p:sp>
-      <p:sp>
-        <p:nvSpPr>
-          <p:cNvPr id="4" name="Slide Number Placeholder 3"/>
-          <p:cNvSpPr>
-            <a:spLocks noGrp="1"/>
-          </p:cNvSpPr>
-          <p:nvPr>
-            <p:ph type="sldNum" sz="quarter" idx="10"/>
-          </p:nvPr>
-        </p:nvSpPr>
-        <p:spPr/>
-        <p:txBody>
-          <a:bodyPr/>
-          <a:lstStyle/>
-          <a:p>
-            <a:fld id="{F7021451-1387-4CA6-816F-3879F97B5CBC}" type="slidenum">
-              <a:rPr lang="en-US"/>
-              <a:t>12</a:t>
-            </a:fld>
-            <a:endParaRPr lang="en-US"/>
-          </a:p>
-        </p:txBody>
-      </p:sp>
-    </p:spTree>
-    <p:extLst>
-      <p:ext uri="{BB962C8B-B14F-4D97-AF65-F5344CB8AC3E}">
-        <p14:creationId xmlns:p14="http://schemas.microsoft.com/office/powerpoint/2010/main" val="1024086991"/>
-      </p:ext>
-    </p:extLst>
-  </p:cSld>
-  <p:clrMapOvr>
-    <a:masterClrMapping/>
-  </p:clrMapOvr>
-</p:notes>
-</file>
-
-<file path=ppt/notesSlides/notesSlide13.xml><?xml version="1.0" encoding="utf-8"?>
-<p:notes xmlns:a="http://schemas.openxmlformats.org/drawingml/2006/main" xmlns:r="http://schemas.openxmlformats.org/officeDocument/2006/relationships" xmlns:p="http://schemas.openxmlformats.org/presentationml/2006/main">
-  <p:cSld>
-    <p:spTree>
-      <p:nvGrpSpPr>
-        <p:cNvPr id="1" name=""/>
-        <p:cNvGrpSpPr/>
-        <p:nvPr/>
-      </p:nvGrpSpPr>
-      <p:grpSpPr>
-        <a:xfrm>
-          <a:off x="0" y="0"/>
-          <a:ext cx="0" cy="0"/>
-          <a:chOff x="0" y="0"/>
-          <a:chExt cx="0" cy="0"/>
-        </a:xfrm>
-      </p:grpSpPr>
-      <p:sp>
-        <p:nvSpPr>
-          <p:cNvPr id="2" name="Slide Image Placeholder 1"/>
-          <p:cNvSpPr>
-            <a:spLocks noGrp="1" noRot="1" noChangeAspect="1"/>
-          </p:cNvSpPr>
-          <p:nvPr>
-            <p:ph type="sldImg"/>
-          </p:nvPr>
-        </p:nvSpPr>
-        <p:spPr/>
-      </p:sp>
-      <p:sp>
-        <p:nvSpPr>
-          <p:cNvPr id="3" name="Notes Placeholder 2"/>
-          <p:cNvSpPr>
-            <a:spLocks noGrp="1"/>
-          </p:cNvSpPr>
-          <p:nvPr>
-            <p:ph type="body" idx="1"/>
-          </p:nvPr>
-        </p:nvSpPr>
-        <p:spPr/>
-        <p:txBody>
-          <a:bodyPr/>
-          <a:lstStyle/>
-          <a:p>
-            <a:r>
-              <a:rPr lang="en-US" dirty="0"/>
-              <a:t/>
-            </a:r>
-            <a:endParaRPr lang="en-US" dirty="0"/>
-          </a:p>
-        </p:txBody>
-      </p:sp>
-      <p:sp>
-        <p:nvSpPr>
-          <p:cNvPr id="4" name="Slide Number Placeholder 3"/>
-          <p:cNvSpPr>
-            <a:spLocks noGrp="1"/>
-          </p:cNvSpPr>
-          <p:nvPr>
-            <p:ph type="sldNum" sz="quarter" idx="10"/>
-          </p:nvPr>
-        </p:nvSpPr>
-        <p:spPr/>
-        <p:txBody>
-          <a:bodyPr/>
-          <a:lstStyle/>
-          <a:p>
-            <a:fld id="{F7021451-1387-4CA6-816F-3879F97B5CBC}" type="slidenum">
-              <a:rPr lang="en-US"/>
-              <a:t>13</a:t>
-            </a:fld>
-            <a:endParaRPr lang="en-US"/>
-          </a:p>
-        </p:txBody>
-      </p:sp>
-    </p:spTree>
-    <p:extLst>
-      <p:ext uri="{BB962C8B-B14F-4D97-AF65-F5344CB8AC3E}">
-        <p14:creationId xmlns:p14="http://schemas.microsoft.com/office/powerpoint/2010/main" val="1024086991"/>
-      </p:ext>
-    </p:extLst>
-  </p:cSld>
-  <p:clrMapOvr>
-    <a:masterClrMapping/>
-  </p:clrMapOvr>
-</p:notes>
-</file>
-
-<file path=ppt/notesSlides/notesSlide14.xml><?xml version="1.0" encoding="utf-8"?>
-<p:notes xmlns:a="http://schemas.openxmlformats.org/drawingml/2006/main" xmlns:r="http://schemas.openxmlformats.org/officeDocument/2006/relationships" xmlns:p="http://schemas.openxmlformats.org/presentationml/2006/main">
-  <p:cSld>
-    <p:spTree>
-      <p:nvGrpSpPr>
-        <p:cNvPr id="1" name=""/>
-        <p:cNvGrpSpPr/>
-        <p:nvPr/>
-      </p:nvGrpSpPr>
-      <p:grpSpPr>
-        <a:xfrm>
-          <a:off x="0" y="0"/>
-          <a:ext cx="0" cy="0"/>
-          <a:chOff x="0" y="0"/>
-          <a:chExt cx="0" cy="0"/>
-        </a:xfrm>
-      </p:grpSpPr>
-      <p:sp>
-        <p:nvSpPr>
-          <p:cNvPr id="2" name="Slide Image Placeholder 1"/>
-          <p:cNvSpPr>
-            <a:spLocks noGrp="1" noRot="1" noChangeAspect="1"/>
-          </p:cNvSpPr>
-          <p:nvPr>
-            <p:ph type="sldImg"/>
-          </p:nvPr>
-        </p:nvSpPr>
-        <p:spPr/>
-      </p:sp>
-      <p:sp>
-        <p:nvSpPr>
-          <p:cNvPr id="3" name="Notes Placeholder 2"/>
-          <p:cNvSpPr>
-            <a:spLocks noGrp="1"/>
-          </p:cNvSpPr>
-          <p:nvPr>
-            <p:ph type="body" idx="1"/>
-          </p:nvPr>
-        </p:nvSpPr>
-        <p:spPr/>
-        <p:txBody>
-          <a:bodyPr/>
-          <a:lstStyle/>
-          <a:p>
-            <a:r>
-              <a:rPr lang="en-US" dirty="0"/>
-              <a:t/>
-            </a:r>
-            <a:endParaRPr lang="en-US" dirty="0"/>
-          </a:p>
-        </p:txBody>
-      </p:sp>
-      <p:sp>
-        <p:nvSpPr>
-          <p:cNvPr id="4" name="Slide Number Placeholder 3"/>
-          <p:cNvSpPr>
-            <a:spLocks noGrp="1"/>
-          </p:cNvSpPr>
-          <p:nvPr>
-            <p:ph type="sldNum" sz="quarter" idx="10"/>
-          </p:nvPr>
-        </p:nvSpPr>
-        <p:spPr/>
-        <p:txBody>
-          <a:bodyPr/>
-          <a:lstStyle/>
-          <a:p>
-            <a:fld id="{F7021451-1387-4CA6-816F-3879F97B5CBC}" type="slidenum">
-              <a:rPr lang="en-US"/>
-              <a:t>14</a:t>
-            </a:fld>
-            <a:endParaRPr lang="en-US"/>
-          </a:p>
-        </p:txBody>
-      </p:sp>
-    </p:spTree>
-    <p:extLst>
-      <p:ext uri="{BB962C8B-B14F-4D97-AF65-F5344CB8AC3E}">
-        <p14:creationId xmlns:p14="http://schemas.microsoft.com/office/powerpoint/2010/main" val="1024086991"/>
-      </p:ext>
-    </p:extLst>
-  </p:cSld>
-  <p:clrMapOvr>
-    <a:masterClrMapping/>
-  </p:clrMapOvr>
-</p:notes>
-</file>
-
-<file path=ppt/notesSlides/notesSlide15.xml><?xml version="1.0" encoding="utf-8"?>
-<p:notes xmlns:a="http://schemas.openxmlformats.org/drawingml/2006/main" xmlns:r="http://schemas.openxmlformats.org/officeDocument/2006/relationships" xmlns:p="http://schemas.openxmlformats.org/presentationml/2006/main">
-  <p:cSld>
-    <p:spTree>
-      <p:nvGrpSpPr>
-        <p:cNvPr id="1" name=""/>
-        <p:cNvGrpSpPr/>
-        <p:nvPr/>
-      </p:nvGrpSpPr>
-      <p:grpSpPr>
-        <a:xfrm>
-          <a:off x="0" y="0"/>
-          <a:ext cx="0" cy="0"/>
-          <a:chOff x="0" y="0"/>
-          <a:chExt cx="0" cy="0"/>
-        </a:xfrm>
-      </p:grpSpPr>
-      <p:sp>
-        <p:nvSpPr>
-          <p:cNvPr id="2" name="Slide Image Placeholder 1"/>
-          <p:cNvSpPr>
-            <a:spLocks noGrp="1" noRot="1" noChangeAspect="1"/>
-          </p:cNvSpPr>
-          <p:nvPr>
-            <p:ph type="sldImg"/>
-          </p:nvPr>
-        </p:nvSpPr>
-        <p:spPr/>
-      </p:sp>
-      <p:sp>
-        <p:nvSpPr>
-          <p:cNvPr id="3" name="Notes Placeholder 2"/>
-          <p:cNvSpPr>
-            <a:spLocks noGrp="1"/>
-          </p:cNvSpPr>
-          <p:nvPr>
-            <p:ph type="body" idx="1"/>
-          </p:nvPr>
-        </p:nvSpPr>
-        <p:spPr/>
-        <p:txBody>
-          <a:bodyPr/>
-          <a:lstStyle/>
-          <a:p>
-            <a:r>
-              <a:rPr lang="en-US" dirty="0"/>
-              <a:t/>
-            </a:r>
-            <a:endParaRPr lang="en-US" dirty="0"/>
-          </a:p>
-        </p:txBody>
-      </p:sp>
-      <p:sp>
-        <p:nvSpPr>
-          <p:cNvPr id="4" name="Slide Number Placeholder 3"/>
-          <p:cNvSpPr>
-            <a:spLocks noGrp="1"/>
-          </p:cNvSpPr>
-          <p:nvPr>
-            <p:ph type="sldNum" sz="quarter" idx="10"/>
-          </p:nvPr>
-        </p:nvSpPr>
-        <p:spPr/>
-        <p:txBody>
-          <a:bodyPr/>
-          <a:lstStyle/>
-          <a:p>
-            <a:fld id="{F7021451-1387-4CA6-816F-3879F97B5CBC}" type="slidenum">
-              <a:rPr lang="en-US"/>
-              <a:t>15</a:t>
-            </a:fld>
-            <a:endParaRPr lang="en-US"/>
-          </a:p>
-        </p:txBody>
-      </p:sp>
-    </p:spTree>
-    <p:extLst>
-      <p:ext uri="{BB962C8B-B14F-4D97-AF65-F5344CB8AC3E}">
-        <p14:creationId xmlns:p14="http://schemas.microsoft.com/office/powerpoint/2010/main" val="1024086991"/>
-      </p:ext>
-    </p:extLst>
-  </p:cSld>
-  <p:clrMapOvr>
-    <a:masterClrMapping/>
-  </p:clrMapOvr>
-</p:notes>
-</file>
-
-<file path=ppt/notesSlides/notesSlide16.xml><?xml version="1.0" encoding="utf-8"?>
-<p:notes xmlns:a="http://schemas.openxmlformats.org/drawingml/2006/main" xmlns:r="http://schemas.openxmlformats.org/officeDocument/2006/relationships" xmlns:p="http://schemas.openxmlformats.org/presentationml/2006/main">
-  <p:cSld>
-    <p:spTree>
-      <p:nvGrpSpPr>
-        <p:cNvPr id="1" name=""/>
-        <p:cNvGrpSpPr/>
-        <p:nvPr/>
-      </p:nvGrpSpPr>
-      <p:grpSpPr>
-        <a:xfrm>
-          <a:off x="0" y="0"/>
-          <a:ext cx="0" cy="0"/>
-          <a:chOff x="0" y="0"/>
-          <a:chExt cx="0" cy="0"/>
-        </a:xfrm>
-      </p:grpSpPr>
-      <p:sp>
-        <p:nvSpPr>
-          <p:cNvPr id="2" name="Slide Image Placeholder 1"/>
-          <p:cNvSpPr>
-            <a:spLocks noGrp="1" noRot="1" noChangeAspect="1"/>
-          </p:cNvSpPr>
-          <p:nvPr>
-            <p:ph type="sldImg"/>
-          </p:nvPr>
-        </p:nvSpPr>
-        <p:spPr/>
-      </p:sp>
-      <p:sp>
-        <p:nvSpPr>
-          <p:cNvPr id="3" name="Notes Placeholder 2"/>
-          <p:cNvSpPr>
-            <a:spLocks noGrp="1"/>
-          </p:cNvSpPr>
-          <p:nvPr>
-            <p:ph type="body" idx="1"/>
-          </p:nvPr>
-        </p:nvSpPr>
-        <p:spPr/>
-        <p:txBody>
-          <a:bodyPr/>
-          <a:lstStyle/>
-          <a:p>
-            <a:r>
-              <a:rPr lang="en-US" dirty="0"/>
-              <a:t/>
-            </a:r>
-            <a:endParaRPr lang="en-US" dirty="0"/>
-          </a:p>
-        </p:txBody>
-      </p:sp>
-      <p:sp>
-        <p:nvSpPr>
-          <p:cNvPr id="4" name="Slide Number Placeholder 3"/>
-          <p:cNvSpPr>
-            <a:spLocks noGrp="1"/>
-          </p:cNvSpPr>
-          <p:nvPr>
-            <p:ph type="sldNum" sz="quarter" idx="10"/>
-          </p:nvPr>
-        </p:nvSpPr>
-        <p:spPr/>
-        <p:txBody>
-          <a:bodyPr/>
-          <a:lstStyle/>
-          <a:p>
-            <a:fld id="{F7021451-1387-4CA6-816F-3879F97B5CBC}" type="slidenum">
-              <a:rPr lang="en-US"/>
-              <a:t>16</a:t>
-            </a:fld>
-            <a:endParaRPr lang="en-US"/>
-          </a:p>
-        </p:txBody>
-      </p:sp>
-    </p:spTree>
-    <p:extLst>
-      <p:ext uri="{BB962C8B-B14F-4D97-AF65-F5344CB8AC3E}">
-        <p14:creationId xmlns:p14="http://schemas.microsoft.com/office/powerpoint/2010/main" val="1024086991"/>
-      </p:ext>
-    </p:extLst>
-  </p:cSld>
-  <p:clrMapOvr>
-    <a:masterClrMapping/>
-  </p:clrMapOvr>
-</p:notes>
-</file>
-
 <file path=ppt/notesSlides/notesSlide2.xml><?xml version="1.0" encoding="utf-8"?>
 <p:notes xmlns:a="http://schemas.openxmlformats.org/drawingml/2006/main" xmlns:r="http://schemas.openxmlformats.org/officeDocument/2006/relationships" xmlns:p="http://schemas.openxmlformats.org/presentationml/2006/main">
   <p:cSld>
@@ -1221,7 +690,10 @@
           <a:p>
             <a:r>
               <a:rPr lang="en-US" dirty="0"/>
-              <a:t/>
+              <a:t>Purpose: Background — Part 2
+Key argument: What is known and the gap
+Transition: Next slide covers How the research was conducted
+Suggested duration: ~6s</a:t>
             </a:r>
             <a:endParaRPr lang="en-US" dirty="0"/>
           </a:p>
@@ -1397,7 +869,10 @@
           <a:p>
             <a:r>
               <a:rPr lang="en-US" dirty="0"/>
-              <a:t/>
+              <a:t>Purpose: Methodology — Part 1
+Key argument: How the research was conducted
+Transition: Next slide covers How the research was conducted
+Suggested duration: ~6s</a:t>
             </a:r>
             <a:endParaRPr lang="en-US" dirty="0"/>
           </a:p>
@@ -1485,7 +960,10 @@
           <a:p>
             <a:r>
               <a:rPr lang="en-US" dirty="0"/>
-              <a:t/>
+              <a:t>Purpose: Methodology — Part 2
+Key argument: How the research was conducted
+Transition: Next slide covers What the data shows
+Suggested duration: ~6s</a:t>
             </a:r>
             <a:endParaRPr lang="en-US" dirty="0"/>
           </a:p>
@@ -1661,7 +1139,10 @@
           <a:p>
             <a:r>
               <a:rPr lang="en-US" dirty="0"/>
-              <a:t/>
+              <a:t>Purpose: Results — Part 1
+Key argument: What the data shows
+Transition: Next slide covers What results mean for the field
+Suggested duration: ~6s</a:t>
             </a:r>
             <a:endParaRPr lang="en-US" dirty="0"/>
           </a:p>
@@ -1837,7 +1318,10 @@
           <a:p>
             <a:r>
               <a:rPr lang="en-US" dirty="0"/>
-              <a:t/>
+              <a:t>Purpose: Discussion — Part 1
+Key argument: What results mean for the field
+Transition: Next slide covers Summary and contact information
+Suggested duration: ~6s</a:t>
             </a:r>
             <a:endParaRPr lang="en-US" dirty="0"/>
           </a:p>
@@ -2277,9 +1761,45 @@
                   <a:srgbClr val="1A1A1A"/>
                 </a:solidFill>
               </a:rPr>
-              <a:t>What is known and the gap</a:t>
+              <a:t>Project Phoenix is a next-generation distributed system designed to handle high-throughput event processing with guar...</a:t>
             </a:r>
             <a:endParaRPr lang="en-US" sz="1500" dirty="0"/>
+          </a:p>
+        </p:txBody>
+      </p:sp>
+      <p:sp>
+        <p:nvSpPr>
+          <p:cNvPr id="5" name="Text 2"/>
+          <p:cNvSpPr/>
+          <p:nvPr/>
+        </p:nvSpPr>
+        <p:spPr>
+          <a:xfrm>
+            <a:off x="457200" y="6400800"/>
+            <a:ext cx="7620000" cy="274320"/>
+          </a:xfrm>
+          <a:prstGeom prst="rect">
+            <a:avLst/>
+          </a:prstGeom>
+          <a:noFill/>
+          <a:ln/>
+        </p:spPr>
+        <p:txBody>
+          <a:bodyPr wrap="square" rtlCol="0" anchor="ctr"/>
+          <a:lstStyle/>
+          <a:p>
+            <a:pPr algn="l" indent="0" marL="0">
+              <a:buNone/>
+            </a:pPr>
+            <a:r>
+              <a:rPr lang="en-US" sz="800" dirty="0">
+                <a:solidFill>
+                  <a:srgbClr val="9CA3AF"/>
+                </a:solidFill>
+              </a:rPr>
+              <a:t>para-000, para-001</a:t>
+            </a:r>
+            <a:endParaRPr lang="en-US" sz="800" dirty="0"/>
           </a:p>
         </p:txBody>
       </p:sp>
@@ -2323,599 +1843,6 @@
         </p:nvSpPr>
         <p:spPr>
           <a:xfrm>
-            <a:off x="457200" y="274320"/>
-            <a:ext cx="9144000" cy="731520"/>
-          </a:xfrm>
-          <a:prstGeom prst="rect">
-            <a:avLst/>
-          </a:prstGeom>
-          <a:noFill/>
-          <a:ln/>
-        </p:spPr>
-        <p:txBody>
-          <a:bodyPr wrap="square" rtlCol="0" anchor="ctr"/>
-          <a:lstStyle/>
-          <a:p>
-            <a:pPr indent="0" marL="0">
-              <a:buNone/>
-            </a:pPr>
-            <a:r>
-              <a:rPr lang="en-US" sz="2200" b="1" dirty="0">
-                <a:solidFill>
-                  <a:srgbClr val="1A1A1A"/>
-                </a:solidFill>
-              </a:rPr>
-              <a:t>What the data shows</a:t>
-            </a:r>
-            <a:endParaRPr lang="en-US" sz="2200" dirty="0"/>
-          </a:p>
-        </p:txBody>
-      </p:sp>
-      <p:sp>
-        <p:nvSpPr>
-          <p:cNvPr id="3" name="Text 1"/>
-          <p:cNvSpPr/>
-          <p:nvPr/>
-        </p:nvSpPr>
-        <p:spPr>
-          <a:xfrm>
-            <a:off x="457200" y="1097280"/>
-            <a:ext cx="9144000" cy="5029200"/>
-          </a:xfrm>
-          <a:prstGeom prst="rect">
-            <a:avLst/>
-          </a:prstGeom>
-          <a:noFill/>
-          <a:ln/>
-        </p:spPr>
-        <p:txBody>
-          <a:bodyPr wrap="square" rtlCol="0" anchor="ctr"/>
-          <a:lstStyle/>
-          <a:p>
-            <a:pPr marL="342900" indent="-342900">
-              <a:buSzPct val="100000"/>
-              <a:buChar char="•"/>
-            </a:pPr>
-            <a:r>
-              <a:rPr lang="en-US" sz="1400" dirty="0">
-                <a:solidFill>
-                  <a:srgbClr val="1A1A1A"/>
-                </a:solidFill>
-              </a:rPr>
-              <a:t>What the data shows</a:t>
-            </a:r>
-            <a:endParaRPr lang="en-US" sz="1400" dirty="0"/>
-          </a:p>
-        </p:txBody>
-      </p:sp>
-    </p:spTree>
-  </p:cSld>
-  <p:clrMapOvr>
-    <a:masterClrMapping/>
-  </p:clrMapOvr>
-</p:sld>
-</file>
-
-<file path=ppt/slides/slide11.xml><?xml version="1.0" encoding="utf-8"?>
-<p:sld xmlns:a="http://schemas.openxmlformats.org/drawingml/2006/main" xmlns:r="http://schemas.openxmlformats.org/officeDocument/2006/relationships" xmlns:p="http://schemas.openxmlformats.org/presentationml/2006/main">
-  <p:cSld name="Slide 11">
-    <p:bg>
-      <p:bgPr>
-        <a:solidFill>
-          <a:srgbClr val="FFFFFF"/>
-        </a:solidFill>
-      </p:bgPr>
-    </p:bg>
-    <p:spTree>
-      <p:nvGrpSpPr>
-        <p:cNvPr id="1" name=""/>
-        <p:cNvGrpSpPr/>
-        <p:nvPr/>
-      </p:nvGrpSpPr>
-      <p:grpSpPr>
-        <a:xfrm>
-          <a:off x="0" y="0"/>
-          <a:ext cx="0" cy="0"/>
-          <a:chOff x="0" y="0"/>
-          <a:chExt cx="0" cy="0"/>
-        </a:xfrm>
-      </p:grpSpPr>
-      <p:sp>
-        <p:nvSpPr>
-          <p:cNvPr id="2" name="Text 0"/>
-          <p:cNvSpPr/>
-          <p:nvPr/>
-        </p:nvSpPr>
-        <p:spPr>
-          <a:xfrm>
-            <a:off x="457200" y="274320"/>
-            <a:ext cx="9144000" cy="731520"/>
-          </a:xfrm>
-          <a:prstGeom prst="rect">
-            <a:avLst/>
-          </a:prstGeom>
-          <a:noFill/>
-          <a:ln/>
-        </p:spPr>
-        <p:txBody>
-          <a:bodyPr wrap="square" rtlCol="0" anchor="ctr"/>
-          <a:lstStyle/>
-          <a:p>
-            <a:pPr indent="0" marL="0">
-              <a:buNone/>
-            </a:pPr>
-            <a:r>
-              <a:rPr lang="en-US" sz="2200" b="1" dirty="0">
-                <a:solidFill>
-                  <a:srgbClr val="1A1A1A"/>
-                </a:solidFill>
-              </a:rPr>
-              <a:t>What the data shows</a:t>
-            </a:r>
-            <a:endParaRPr lang="en-US" sz="2200" dirty="0"/>
-          </a:p>
-        </p:txBody>
-      </p:sp>
-      <p:sp>
-        <p:nvSpPr>
-          <p:cNvPr id="3" name="Text 1"/>
-          <p:cNvSpPr/>
-          <p:nvPr/>
-        </p:nvSpPr>
-        <p:spPr>
-          <a:xfrm>
-            <a:off x="457200" y="1097280"/>
-            <a:ext cx="9144000" cy="5029200"/>
-          </a:xfrm>
-          <a:prstGeom prst="rect">
-            <a:avLst/>
-          </a:prstGeom>
-          <a:noFill/>
-          <a:ln/>
-        </p:spPr>
-        <p:txBody>
-          <a:bodyPr wrap="square" rtlCol="0" anchor="ctr"/>
-          <a:lstStyle/>
-          <a:p>
-            <a:pPr marL="342900" indent="-342900">
-              <a:buSzPct val="100000"/>
-              <a:buChar char="•"/>
-            </a:pPr>
-            <a:r>
-              <a:rPr lang="en-US" sz="1400" dirty="0">
-                <a:solidFill>
-                  <a:srgbClr val="1A1A1A"/>
-                </a:solidFill>
-              </a:rPr>
-              <a:t>What the data shows</a:t>
-            </a:r>
-            <a:endParaRPr lang="en-US" sz="1400" dirty="0"/>
-          </a:p>
-        </p:txBody>
-      </p:sp>
-    </p:spTree>
-  </p:cSld>
-  <p:clrMapOvr>
-    <a:masterClrMapping/>
-  </p:clrMapOvr>
-</p:sld>
-</file>
-
-<file path=ppt/slides/slide12.xml><?xml version="1.0" encoding="utf-8"?>
-<p:sld xmlns:a="http://schemas.openxmlformats.org/drawingml/2006/main" xmlns:r="http://schemas.openxmlformats.org/officeDocument/2006/relationships" xmlns:p="http://schemas.openxmlformats.org/presentationml/2006/main">
-  <p:cSld name="Slide 12">
-    <p:bg>
-      <p:bgPr>
-        <a:solidFill>
-          <a:srgbClr val="FFFFFF"/>
-        </a:solidFill>
-      </p:bgPr>
-    </p:bg>
-    <p:spTree>
-      <p:nvGrpSpPr>
-        <p:cNvPr id="1" name=""/>
-        <p:cNvGrpSpPr/>
-        <p:nvPr/>
-      </p:nvGrpSpPr>
-      <p:grpSpPr>
-        <a:xfrm>
-          <a:off x="0" y="0"/>
-          <a:ext cx="0" cy="0"/>
-          <a:chOff x="0" y="0"/>
-          <a:chExt cx="0" cy="0"/>
-        </a:xfrm>
-      </p:grpSpPr>
-      <p:sp>
-        <p:nvSpPr>
-          <p:cNvPr id="2" name="Text 0"/>
-          <p:cNvSpPr/>
-          <p:nvPr/>
-        </p:nvSpPr>
-        <p:spPr>
-          <a:xfrm>
-            <a:off x="914400" y="2286000"/>
-            <a:ext cx="7620000" cy="1828800"/>
-          </a:xfrm>
-          <a:prstGeom prst="rect">
-            <a:avLst/>
-          </a:prstGeom>
-          <a:noFill/>
-          <a:ln/>
-        </p:spPr>
-        <p:txBody>
-          <a:bodyPr wrap="square" rtlCol="0" anchor="ctr"/>
-          <a:lstStyle/>
-          <a:p>
-            <a:pPr algn="ctr" indent="0" marL="0">
-              <a:buNone/>
-            </a:pPr>
-            <a:r>
-              <a:rPr lang="en-US" sz="3600" b="1" dirty="0">
-                <a:solidFill>
-                  <a:srgbClr val="1A1A1A"/>
-                </a:solidFill>
-              </a:rPr>
-              <a:t>Discussion</a:t>
-            </a:r>
-            <a:endParaRPr lang="en-US" sz="3600" dirty="0"/>
-          </a:p>
-        </p:txBody>
-      </p:sp>
-    </p:spTree>
-  </p:cSld>
-  <p:clrMapOvr>
-    <a:masterClrMapping/>
-  </p:clrMapOvr>
-</p:sld>
-</file>
-
-<file path=ppt/slides/slide13.xml><?xml version="1.0" encoding="utf-8"?>
-<p:sld xmlns:a="http://schemas.openxmlformats.org/drawingml/2006/main" xmlns:r="http://schemas.openxmlformats.org/officeDocument/2006/relationships" xmlns:p="http://schemas.openxmlformats.org/presentationml/2006/main">
-  <p:cSld name="Slide 13">
-    <p:bg>
-      <p:bgPr>
-        <a:solidFill>
-          <a:srgbClr val="FFFFFF"/>
-        </a:solidFill>
-      </p:bgPr>
-    </p:bg>
-    <p:spTree>
-      <p:nvGrpSpPr>
-        <p:cNvPr id="1" name=""/>
-        <p:cNvGrpSpPr/>
-        <p:nvPr/>
-      </p:nvGrpSpPr>
-      <p:grpSpPr>
-        <a:xfrm>
-          <a:off x="0" y="0"/>
-          <a:ext cx="0" cy="0"/>
-          <a:chOff x="0" y="0"/>
-          <a:chExt cx="0" cy="0"/>
-        </a:xfrm>
-      </p:grpSpPr>
-      <p:sp>
-        <p:nvSpPr>
-          <p:cNvPr id="2" name="Text 0"/>
-          <p:cNvSpPr/>
-          <p:nvPr/>
-        </p:nvSpPr>
-        <p:spPr>
-          <a:xfrm>
-            <a:off x="457200" y="274320"/>
-            <a:ext cx="7620000" cy="731520"/>
-          </a:xfrm>
-          <a:prstGeom prst="rect">
-            <a:avLst/>
-          </a:prstGeom>
-          <a:noFill/>
-          <a:ln/>
-        </p:spPr>
-        <p:txBody>
-          <a:bodyPr wrap="square" rtlCol="0" anchor="ctr"/>
-          <a:lstStyle/>
-          <a:p>
-            <a:pPr indent="0" marL="0">
-              <a:buNone/>
-            </a:pPr>
-            <a:r>
-              <a:rPr lang="en-US" sz="2400" b="1" dirty="0">
-                <a:solidFill>
-                  <a:srgbClr val="1A1A1A"/>
-                </a:solidFill>
-              </a:rPr>
-              <a:t>What results mean for the field</a:t>
-            </a:r>
-            <a:endParaRPr lang="en-US" sz="2400" dirty="0"/>
-          </a:p>
-        </p:txBody>
-      </p:sp>
-      <p:sp>
-        <p:nvSpPr>
-          <p:cNvPr id="3" name="Text 1"/>
-          <p:cNvSpPr/>
-          <p:nvPr/>
-        </p:nvSpPr>
-        <p:spPr>
-          <a:xfrm>
-            <a:off x="457200" y="1097280"/>
-            <a:ext cx="7620000" cy="5029200"/>
-          </a:xfrm>
-          <a:prstGeom prst="rect">
-            <a:avLst/>
-          </a:prstGeom>
-          <a:noFill/>
-          <a:ln/>
-        </p:spPr>
-        <p:txBody>
-          <a:bodyPr wrap="square" rtlCol="0" anchor="ctr"/>
-          <a:lstStyle/>
-          <a:p>
-            <a:pPr marL="342900" indent="-342900">
-              <a:buSzPct val="100000"/>
-              <a:buChar char="•"/>
-            </a:pPr>
-            <a:r>
-              <a:rPr lang="en-US" sz="1500" dirty="0">
-                <a:solidFill>
-                  <a:srgbClr val="1A1A1A"/>
-                </a:solidFill>
-              </a:rPr>
-              <a:t>What results mean for the field</a:t>
-            </a:r>
-            <a:endParaRPr lang="en-US" sz="1500" dirty="0"/>
-          </a:p>
-        </p:txBody>
-      </p:sp>
-    </p:spTree>
-  </p:cSld>
-  <p:clrMapOvr>
-    <a:masterClrMapping/>
-  </p:clrMapOvr>
-</p:sld>
-</file>
-
-<file path=ppt/slides/slide14.xml><?xml version="1.0" encoding="utf-8"?>
-<p:sld xmlns:a="http://schemas.openxmlformats.org/drawingml/2006/main" xmlns:r="http://schemas.openxmlformats.org/officeDocument/2006/relationships" xmlns:p="http://schemas.openxmlformats.org/presentationml/2006/main">
-  <p:cSld name="Slide 14">
-    <p:bg>
-      <p:bgPr>
-        <a:solidFill>
-          <a:srgbClr val="FFFFFF"/>
-        </a:solidFill>
-      </p:bgPr>
-    </p:bg>
-    <p:spTree>
-      <p:nvGrpSpPr>
-        <p:cNvPr id="1" name=""/>
-        <p:cNvGrpSpPr/>
-        <p:nvPr/>
-      </p:nvGrpSpPr>
-      <p:grpSpPr>
-        <a:xfrm>
-          <a:off x="0" y="0"/>
-          <a:ext cx="0" cy="0"/>
-          <a:chOff x="0" y="0"/>
-          <a:chExt cx="0" cy="0"/>
-        </a:xfrm>
-      </p:grpSpPr>
-      <p:sp>
-        <p:nvSpPr>
-          <p:cNvPr id="2" name="Text 0"/>
-          <p:cNvSpPr/>
-          <p:nvPr/>
-        </p:nvSpPr>
-        <p:spPr>
-          <a:xfrm>
-            <a:off x="457200" y="274320"/>
-            <a:ext cx="7620000" cy="731520"/>
-          </a:xfrm>
-          <a:prstGeom prst="rect">
-            <a:avLst/>
-          </a:prstGeom>
-          <a:noFill/>
-          <a:ln/>
-        </p:spPr>
-        <p:txBody>
-          <a:bodyPr wrap="square" rtlCol="0" anchor="ctr"/>
-          <a:lstStyle/>
-          <a:p>
-            <a:pPr indent="0" marL="0">
-              <a:buNone/>
-            </a:pPr>
-            <a:r>
-              <a:rPr lang="en-US" sz="2400" b="1" dirty="0">
-                <a:solidFill>
-                  <a:srgbClr val="1A1A1A"/>
-                </a:solidFill>
-              </a:rPr>
-              <a:t>What results mean for the field</a:t>
-            </a:r>
-            <a:endParaRPr lang="en-US" sz="2400" dirty="0"/>
-          </a:p>
-        </p:txBody>
-      </p:sp>
-      <p:sp>
-        <p:nvSpPr>
-          <p:cNvPr id="3" name="Text 1"/>
-          <p:cNvSpPr/>
-          <p:nvPr/>
-        </p:nvSpPr>
-        <p:spPr>
-          <a:xfrm>
-            <a:off x="457200" y="1097280"/>
-            <a:ext cx="7620000" cy="5029200"/>
-          </a:xfrm>
-          <a:prstGeom prst="rect">
-            <a:avLst/>
-          </a:prstGeom>
-          <a:noFill/>
-          <a:ln/>
-        </p:spPr>
-        <p:txBody>
-          <a:bodyPr wrap="square" rtlCol="0" anchor="ctr"/>
-          <a:lstStyle/>
-          <a:p>
-            <a:pPr marL="342900" indent="-342900">
-              <a:buSzPct val="100000"/>
-              <a:buChar char="•"/>
-            </a:pPr>
-            <a:r>
-              <a:rPr lang="en-US" sz="1500" dirty="0">
-                <a:solidFill>
-                  <a:srgbClr val="1A1A1A"/>
-                </a:solidFill>
-              </a:rPr>
-              <a:t>What results mean for the field</a:t>
-            </a:r>
-            <a:endParaRPr lang="en-US" sz="1500" dirty="0"/>
-          </a:p>
-        </p:txBody>
-      </p:sp>
-    </p:spTree>
-  </p:cSld>
-  <p:clrMapOvr>
-    <a:masterClrMapping/>
-  </p:clrMapOvr>
-</p:sld>
-</file>
-
-<file path=ppt/slides/slide15.xml><?xml version="1.0" encoding="utf-8"?>
-<p:sld xmlns:a="http://schemas.openxmlformats.org/drawingml/2006/main" xmlns:r="http://schemas.openxmlformats.org/officeDocument/2006/relationships" xmlns:p="http://schemas.openxmlformats.org/presentationml/2006/main">
-  <p:cSld name="Slide 15">
-    <p:bg>
-      <p:bgPr>
-        <a:solidFill>
-          <a:srgbClr val="FFFFFF"/>
-        </a:solidFill>
-      </p:bgPr>
-    </p:bg>
-    <p:spTree>
-      <p:nvGrpSpPr>
-        <p:cNvPr id="1" name=""/>
-        <p:cNvGrpSpPr/>
-        <p:nvPr/>
-      </p:nvGrpSpPr>
-      <p:grpSpPr>
-        <a:xfrm>
-          <a:off x="0" y="0"/>
-          <a:ext cx="0" cy="0"/>
-          <a:chOff x="0" y="0"/>
-          <a:chExt cx="0" cy="0"/>
-        </a:xfrm>
-      </p:grpSpPr>
-      <p:sp>
-        <p:nvSpPr>
-          <p:cNvPr id="2" name="Text 0"/>
-          <p:cNvSpPr/>
-          <p:nvPr/>
-        </p:nvSpPr>
-        <p:spPr>
-          <a:xfrm>
-            <a:off x="457200" y="274320"/>
-            <a:ext cx="7620000" cy="731520"/>
-          </a:xfrm>
-          <a:prstGeom prst="rect">
-            <a:avLst/>
-          </a:prstGeom>
-          <a:noFill/>
-          <a:ln/>
-        </p:spPr>
-        <p:txBody>
-          <a:bodyPr wrap="square" rtlCol="0" anchor="ctr"/>
-          <a:lstStyle/>
-          <a:p>
-            <a:pPr indent="0" marL="0">
-              <a:buNone/>
-            </a:pPr>
-            <a:r>
-              <a:rPr lang="en-US" sz="2400" b="1" dirty="0">
-                <a:solidFill>
-                  <a:srgbClr val="1A1A1A"/>
-                </a:solidFill>
-              </a:rPr>
-              <a:t>What results mean for the field</a:t>
-            </a:r>
-            <a:endParaRPr lang="en-US" sz="2400" dirty="0"/>
-          </a:p>
-        </p:txBody>
-      </p:sp>
-      <p:sp>
-        <p:nvSpPr>
-          <p:cNvPr id="3" name="Text 1"/>
-          <p:cNvSpPr/>
-          <p:nvPr/>
-        </p:nvSpPr>
-        <p:spPr>
-          <a:xfrm>
-            <a:off x="457200" y="1097280"/>
-            <a:ext cx="7620000" cy="5029200"/>
-          </a:xfrm>
-          <a:prstGeom prst="rect">
-            <a:avLst/>
-          </a:prstGeom>
-          <a:noFill/>
-          <a:ln/>
-        </p:spPr>
-        <p:txBody>
-          <a:bodyPr wrap="square" rtlCol="0" anchor="ctr"/>
-          <a:lstStyle/>
-          <a:p>
-            <a:pPr marL="342900" indent="-342900">
-              <a:buSzPct val="100000"/>
-              <a:buChar char="•"/>
-            </a:pPr>
-            <a:r>
-              <a:rPr lang="en-US" sz="1500" dirty="0">
-                <a:solidFill>
-                  <a:srgbClr val="1A1A1A"/>
-                </a:solidFill>
-              </a:rPr>
-              <a:t>What results mean for the field</a:t>
-            </a:r>
-            <a:endParaRPr lang="en-US" sz="1500" dirty="0"/>
-          </a:p>
-        </p:txBody>
-      </p:sp>
-    </p:spTree>
-  </p:cSld>
-  <p:clrMapOvr>
-    <a:masterClrMapping/>
-  </p:clrMapOvr>
-</p:sld>
-</file>
-
-<file path=ppt/slides/slide16.xml><?xml version="1.0" encoding="utf-8"?>
-<p:sld xmlns:a="http://schemas.openxmlformats.org/drawingml/2006/main" xmlns:r="http://schemas.openxmlformats.org/officeDocument/2006/relationships" xmlns:p="http://schemas.openxmlformats.org/presentationml/2006/main">
-  <p:cSld name="Slide 16">
-    <p:bg>
-      <p:bgPr>
-        <a:solidFill>
-          <a:srgbClr val="FFFFFF"/>
-        </a:solidFill>
-      </p:bgPr>
-    </p:bg>
-    <p:spTree>
-      <p:nvGrpSpPr>
-        <p:cNvPr id="1" name=""/>
-        <p:cNvGrpSpPr/>
-        <p:nvPr/>
-      </p:nvGrpSpPr>
-      <p:grpSpPr>
-        <a:xfrm>
-          <a:off x="0" y="0"/>
-          <a:ext cx="0" cy="0"/>
-          <a:chOff x="0" y="0"/>
-          <a:chExt cx="0" cy="0"/>
-        </a:xfrm>
-      </p:grpSpPr>
-      <p:sp>
-        <p:nvSpPr>
-          <p:cNvPr id="2" name="Text 0"/>
-          <p:cNvSpPr/>
-          <p:nvPr/>
-        </p:nvSpPr>
-        <p:spPr>
-          <a:xfrm>
             <a:off x="914400" y="2286000"/>
             <a:ext cx="7620000" cy="1371600"/>
           </a:xfrm>
@@ -3079,9 +2006,45 @@
                   <a:srgbClr val="1A1A1A"/>
                 </a:solidFill>
               </a:rPr>
-              <a:t>What is known and the gap</a:t>
+              <a:t>Our existing monolithic architecture faces several critical limitations:</a:t>
             </a:r>
             <a:endParaRPr lang="en-US" sz="1500" dirty="0"/>
+          </a:p>
+        </p:txBody>
+      </p:sp>
+      <p:sp>
+        <p:nvSpPr>
+          <p:cNvPr id="5" name="Text 2"/>
+          <p:cNvSpPr/>
+          <p:nvPr/>
+        </p:nvSpPr>
+        <p:spPr>
+          <a:xfrm>
+            <a:off x="457200" y="6400800"/>
+            <a:ext cx="7620000" cy="274320"/>
+          </a:xfrm>
+          <a:prstGeom prst="rect">
+            <a:avLst/>
+          </a:prstGeom>
+          <a:noFill/>
+          <a:ln/>
+        </p:spPr>
+        <p:txBody>
+          <a:bodyPr wrap="square" rtlCol="0" anchor="ctr"/>
+          <a:lstStyle/>
+          <a:p>
+            <a:pPr algn="l" indent="0" marL="0">
+              <a:buNone/>
+            </a:pPr>
+            <a:r>
+              <a:rPr lang="en-US" sz="800" dirty="0">
+                <a:solidFill>
+                  <a:srgbClr val="9CA3AF"/>
+                </a:solidFill>
+              </a:rPr>
+              <a:t>para-000, para-001</a:t>
+            </a:r>
+            <a:endParaRPr lang="en-US" sz="800" dirty="0"/>
           </a:p>
         </p:txBody>
       </p:sp>
@@ -3125,8 +2088,8 @@
         </p:nvSpPr>
         <p:spPr>
           <a:xfrm>
-            <a:off x="457200" y="274320"/>
-            <a:ext cx="7620000" cy="731520"/>
+            <a:off x="914400" y="2286000"/>
+            <a:ext cx="7620000" cy="1828800"/>
           </a:xfrm>
           <a:prstGeom prst="rect">
             <a:avLst/>
@@ -3138,18 +2101,18 @@
           <a:bodyPr wrap="square" rtlCol="0" anchor="ctr"/>
           <a:lstStyle/>
           <a:p>
-            <a:pPr indent="0" marL="0">
+            <a:pPr algn="ctr" indent="0" marL="0">
               <a:buNone/>
             </a:pPr>
             <a:r>
-              <a:rPr lang="en-US" sz="2400" b="1" dirty="0">
+              <a:rPr lang="en-US" sz="3600" b="1" dirty="0">
                 <a:solidFill>
                   <a:srgbClr val="1A1A1A"/>
                 </a:solidFill>
               </a:rPr>
-              <a:t>What is known and the gap</a:t>
-            </a:r>
-            <a:endParaRPr lang="en-US" sz="2400" dirty="0"/>
+              <a:t>Methodology</a:t>
+            </a:r>
+            <a:endParaRPr lang="en-US" sz="3600" dirty="0"/>
           </a:p>
         </p:txBody>
       </p:sp>
@@ -3161,8 +2124,8 @@
         </p:nvSpPr>
         <p:spPr>
           <a:xfrm>
-            <a:off x="457200" y="1097280"/>
-            <a:ext cx="7620000" cy="5029200"/>
+            <a:off x="457200" y="6400800"/>
+            <a:ext cx="7620000" cy="274320"/>
           </a:xfrm>
           <a:prstGeom prst="rect">
             <a:avLst/>
@@ -3174,19 +2137,18 @@
           <a:bodyPr wrap="square" rtlCol="0" anchor="ctr"/>
           <a:lstStyle/>
           <a:p>
-            <a:pPr marL="342900" indent="-342900">
-              <a:buSzPct val="100000"/>
-              <a:buChar char="•"/>
+            <a:pPr algn="l" indent="0" marL="0">
+              <a:buNone/>
             </a:pPr>
             <a:r>
-              <a:rPr lang="en-US" sz="1500" dirty="0">
+              <a:rPr lang="en-US" sz="800" dirty="0">
                 <a:solidFill>
-                  <a:srgbClr val="1A1A1A"/>
+                  <a:srgbClr val="9CA3AF"/>
                 </a:solidFill>
               </a:rPr>
-              <a:t>What is known and the gap</a:t>
-            </a:r>
-            <a:endParaRPr lang="en-US" sz="1500" dirty="0"/>
+              <a:t>para-002, para-003</a:t>
+            </a:r>
+            <a:endParaRPr lang="en-US" sz="800" dirty="0"/>
           </a:p>
         </p:txBody>
       </p:sp>
@@ -3230,8 +2192,8 @@
         </p:nvSpPr>
         <p:spPr>
           <a:xfrm>
-            <a:off x="914400" y="2286000"/>
-            <a:ext cx="7620000" cy="1828800"/>
+            <a:off x="457200" y="274320"/>
+            <a:ext cx="7620000" cy="731520"/>
           </a:xfrm>
           <a:prstGeom prst="rect">
             <a:avLst/>
@@ -3243,18 +2205,91 @@
           <a:bodyPr wrap="square" rtlCol="0" anchor="ctr"/>
           <a:lstStyle/>
           <a:p>
-            <a:pPr algn="ctr" indent="0" marL="0">
+            <a:pPr indent="0" marL="0">
               <a:buNone/>
             </a:pPr>
             <a:r>
-              <a:rPr lang="en-US" sz="3600" b="1" dirty="0">
+              <a:rPr lang="en-US" sz="1800" b="1" dirty="0">
                 <a:solidFill>
                   <a:srgbClr val="1A1A1A"/>
                 </a:solidFill>
               </a:rPr>
-              <a:t>Methodology</a:t>
-            </a:r>
-            <a:endParaRPr lang="en-US" sz="3600" dirty="0"/>
+              <a:t>How the research was conducted</a:t>
+            </a:r>
+            <a:endParaRPr lang="en-US" sz="1800" dirty="0"/>
+          </a:p>
+        </p:txBody>
+      </p:sp>
+      <p:sp>
+        <p:nvSpPr>
+          <p:cNvPr id="3" name="Text 1"/>
+          <p:cNvSpPr/>
+          <p:nvPr/>
+        </p:nvSpPr>
+        <p:spPr>
+          <a:xfrm>
+            <a:off x="457200" y="1097280"/>
+            <a:ext cx="7620000" cy="5029200"/>
+          </a:xfrm>
+          <a:prstGeom prst="rect">
+            <a:avLst/>
+          </a:prstGeom>
+          <a:noFill/>
+          <a:ln/>
+        </p:spPr>
+        <p:txBody>
+          <a:bodyPr wrap="square" rtlCol="0" anchor="ctr"/>
+          <a:lstStyle/>
+          <a:p>
+            <a:pPr marL="342900" indent="-342900">
+              <a:buSzPct val="100000"/>
+              <a:buChar char="•"/>
+            </a:pPr>
+            <a:r>
+              <a:rPr lang="en-US" sz="1300" dirty="0">
+                <a:solidFill>
+                  <a:srgbClr val="1A1A1A"/>
+                </a:solidFill>
+              </a:rPr>
+              <a:t>We propose decomposing the system into six bounded contexts:</a:t>
+            </a:r>
+            <a:endParaRPr lang="en-US" sz="1300" dirty="0"/>
+          </a:p>
+        </p:txBody>
+      </p:sp>
+      <p:sp>
+        <p:nvSpPr>
+          <p:cNvPr id="5" name="Text 2"/>
+          <p:cNvSpPr/>
+          <p:nvPr/>
+        </p:nvSpPr>
+        <p:spPr>
+          <a:xfrm>
+            <a:off x="457200" y="6400800"/>
+            <a:ext cx="7620000" cy="274320"/>
+          </a:xfrm>
+          <a:prstGeom prst="rect">
+            <a:avLst/>
+          </a:prstGeom>
+          <a:noFill/>
+          <a:ln/>
+        </p:spPr>
+        <p:txBody>
+          <a:bodyPr wrap="square" rtlCol="0" anchor="ctr"/>
+          <a:lstStyle/>
+          <a:p>
+            <a:pPr algn="l" indent="0" marL="0">
+              <a:buNone/>
+            </a:pPr>
+            <a:r>
+              <a:rPr lang="en-US" sz="800" dirty="0">
+                <a:solidFill>
+                  <a:srgbClr val="9CA3AF"/>
+                </a:solidFill>
+              </a:rPr>
+              <a:t>para-002, para-003</a:t>
+            </a:r>
+            <a:endParaRPr lang="en-US" sz="800" dirty="0"/>
           </a:p>
         </p:txBody>
       </p:sp>
@@ -3315,14 +2350,14 @@
               <a:buNone/>
             </a:pPr>
             <a:r>
-              <a:rPr lang="en-US" sz="2400" b="1" dirty="0">
+              <a:rPr lang="en-US" sz="1800" b="1" dirty="0">
                 <a:solidFill>
                   <a:srgbClr val="1A1A1A"/>
                 </a:solidFill>
               </a:rPr>
               <a:t>How the research was conducted</a:t>
             </a:r>
-            <a:endParaRPr lang="en-US" sz="2400" dirty="0"/>
+            <a:endParaRPr lang="en-US" sz="1800" dirty="0"/>
           </a:p>
         </p:txBody>
       </p:sp>
@@ -3352,14 +2387,50 @@
               <a:buChar char="•"/>
             </a:pPr>
             <a:r>
-              <a:rPr lang="en-US" sz="1500" dirty="0">
+              <a:rPr lang="en-US" sz="1300" dirty="0">
                 <a:solidFill>
                   <a:srgbClr val="1A1A1A"/>
                 </a:solidFill>
               </a:rPr>
-              <a:t>How the research was conducted</a:t>
-            </a:r>
-            <a:endParaRPr lang="en-US" sz="1500" dirty="0"/>
+              <a:t>The system follows an event-driven architecture:</a:t>
+            </a:r>
+            <a:endParaRPr lang="en-US" sz="1300" dirty="0"/>
+          </a:p>
+        </p:txBody>
+      </p:sp>
+      <p:sp>
+        <p:nvSpPr>
+          <p:cNvPr id="5" name="Text 2"/>
+          <p:cNvSpPr/>
+          <p:nvPr/>
+        </p:nvSpPr>
+        <p:spPr>
+          <a:xfrm>
+            <a:off x="457200" y="6400800"/>
+            <a:ext cx="7620000" cy="274320"/>
+          </a:xfrm>
+          <a:prstGeom prst="rect">
+            <a:avLst/>
+          </a:prstGeom>
+          <a:noFill/>
+          <a:ln/>
+        </p:spPr>
+        <p:txBody>
+          <a:bodyPr wrap="square" rtlCol="0" anchor="ctr"/>
+          <a:lstStyle/>
+          <a:p>
+            <a:pPr algn="l" indent="0" marL="0">
+              <a:buNone/>
+            </a:pPr>
+            <a:r>
+              <a:rPr lang="en-US" sz="800" dirty="0">
+                <a:solidFill>
+                  <a:srgbClr val="9CA3AF"/>
+                </a:solidFill>
+              </a:rPr>
+              <a:t>para-002, para-003</a:t>
+            </a:r>
+            <a:endParaRPr lang="en-US" sz="800" dirty="0"/>
           </a:p>
         </p:txBody>
       </p:sp>
@@ -3403,8 +2474,8 @@
         </p:nvSpPr>
         <p:spPr>
           <a:xfrm>
-            <a:off x="457200" y="274320"/>
-            <a:ext cx="7620000" cy="731520"/>
+            <a:off x="914400" y="2286000"/>
+            <a:ext cx="7620000" cy="1828800"/>
           </a:xfrm>
           <a:prstGeom prst="rect">
             <a:avLst/>
@@ -3416,18 +2487,18 @@
           <a:bodyPr wrap="square" rtlCol="0" anchor="ctr"/>
           <a:lstStyle/>
           <a:p>
-            <a:pPr indent="0" marL="0">
+            <a:pPr algn="ctr" indent="0" marL="0">
               <a:buNone/>
             </a:pPr>
             <a:r>
-              <a:rPr lang="en-US" sz="2400" b="1" dirty="0">
+              <a:rPr lang="en-US" sz="3600" b="1" dirty="0">
                 <a:solidFill>
                   <a:srgbClr val="1A1A1A"/>
                 </a:solidFill>
               </a:rPr>
-              <a:t>How the research was conducted</a:t>
-            </a:r>
-            <a:endParaRPr lang="en-US" sz="2400" dirty="0"/>
+              <a:t>Results</a:t>
+            </a:r>
+            <a:endParaRPr lang="en-US" sz="3600" dirty="0"/>
           </a:p>
         </p:txBody>
       </p:sp>
@@ -3439,8 +2510,8 @@
         </p:nvSpPr>
         <p:spPr>
           <a:xfrm>
-            <a:off x="457200" y="1097280"/>
-            <a:ext cx="7620000" cy="5029200"/>
+            <a:off x="457200" y="6400800"/>
+            <a:ext cx="7620000" cy="274320"/>
           </a:xfrm>
           <a:prstGeom prst="rect">
             <a:avLst/>
@@ -3452,19 +2523,18 @@
           <a:bodyPr wrap="square" rtlCol="0" anchor="ctr"/>
           <a:lstStyle/>
           <a:p>
-            <a:pPr marL="342900" indent="-342900">
-              <a:buSzPct val="100000"/>
-              <a:buChar char="•"/>
+            <a:pPr algn="l" indent="0" marL="0">
+              <a:buNone/>
             </a:pPr>
             <a:r>
-              <a:rPr lang="en-US" sz="1500" dirty="0">
+              <a:rPr lang="en-US" sz="800" dirty="0">
                 <a:solidFill>
-                  <a:srgbClr val="1A1A1A"/>
+                  <a:srgbClr val="9CA3AF"/>
                 </a:solidFill>
               </a:rPr>
-              <a:t>How the research was conducted</a:t>
-            </a:r>
-            <a:endParaRPr lang="en-US" sz="1500" dirty="0"/>
+              <a:t>para-004, para-005</a:t>
+            </a:r>
+            <a:endParaRPr lang="en-US" sz="800" dirty="0"/>
           </a:p>
         </p:txBody>
       </p:sp>
@@ -3509,7 +2579,7 @@
         <p:spPr>
           <a:xfrm>
             <a:off x="457200" y="274320"/>
-            <a:ext cx="7620000" cy="731520"/>
+            <a:ext cx="6858000" cy="731520"/>
           </a:xfrm>
           <a:prstGeom prst="rect">
             <a:avLst/>
@@ -3525,14 +2595,14 @@
               <a:buNone/>
             </a:pPr>
             <a:r>
-              <a:rPr lang="en-US" sz="2400" b="1" dirty="0">
+              <a:rPr lang="en-US" sz="2000" b="1" dirty="0">
                 <a:solidFill>
                   <a:srgbClr val="1A1A1A"/>
                 </a:solidFill>
               </a:rPr>
-              <a:t>How the research was conducted</a:t>
-            </a:r>
-            <a:endParaRPr lang="en-US" sz="2400" dirty="0"/>
+              <a:t>What the data shows</a:t>
+            </a:r>
+            <a:endParaRPr lang="en-US" sz="2000" dirty="0"/>
           </a:p>
         </p:txBody>
       </p:sp>
@@ -3545,7 +2615,7 @@
         <p:spPr>
           <a:xfrm>
             <a:off x="457200" y="1097280"/>
-            <a:ext cx="7620000" cy="5029200"/>
+            <a:ext cx="6858000" cy="5029200"/>
           </a:xfrm>
           <a:prstGeom prst="rect">
             <a:avLst/>
@@ -3562,14 +2632,65 @@
               <a:buChar char="•"/>
             </a:pPr>
             <a:r>
-              <a:rPr lang="en-US" sz="1500" dirty="0">
+              <a:rPr lang="en-US" sz="1400" dirty="0">
                 <a:solidFill>
                   <a:srgbClr val="1A1A1A"/>
                 </a:solidFill>
               </a:rPr>
-              <a:t>How the research was conducted</a:t>
-            </a:r>
-            <a:endParaRPr lang="en-US" sz="1500" dirty="0"/>
+              <a:t>After full implementation, we project:</a:t>
+            </a:r>
+            <a:endParaRPr lang="en-US" sz="1400" dirty="0"/>
+          </a:p>
+          <a:p>
+            <a:pPr marL="342900" indent="-342900">
+              <a:buSzPct val="100000"/>
+              <a:buChar char="•"/>
+            </a:pPr>
+            <a:r>
+              <a:rPr lang="en-US" sz="1400" dirty="0">
+                <a:solidFill>
+                  <a:srgbClr val="1A1A1A"/>
+                </a:solidFill>
+              </a:rPr>
+              <a:t>Project Phoenix represents a fundamental shift from our current reactive architecture to a proactive, event-driven sy...</a:t>
+            </a:r>
+            <a:endParaRPr lang="en-US" sz="1400" dirty="0"/>
+          </a:p>
+        </p:txBody>
+      </p:sp>
+      <p:sp>
+        <p:nvSpPr>
+          <p:cNvPr id="5" name="Text 2"/>
+          <p:cNvSpPr/>
+          <p:nvPr/>
+        </p:nvSpPr>
+        <p:spPr>
+          <a:xfrm>
+            <a:off x="457200" y="6400800"/>
+            <a:ext cx="6858000" cy="274320"/>
+          </a:xfrm>
+          <a:prstGeom prst="rect">
+            <a:avLst/>
+          </a:prstGeom>
+          <a:noFill/>
+          <a:ln/>
+        </p:spPr>
+        <p:txBody>
+          <a:bodyPr wrap="square" rtlCol="0" anchor="ctr"/>
+          <a:lstStyle/>
+          <a:p>
+            <a:pPr algn="l" indent="0" marL="0">
+              <a:buNone/>
+            </a:pPr>
+            <a:r>
+              <a:rPr lang="en-US" sz="800" dirty="0">
+                <a:solidFill>
+                  <a:srgbClr val="9CA3AF"/>
+                </a:solidFill>
+              </a:rPr>
+              <a:t>para-004, para-005</a:t>
+            </a:r>
+            <a:endParaRPr lang="en-US" sz="800" dirty="0"/>
           </a:p>
         </p:txBody>
       </p:sp>
@@ -3635,7 +2756,7 @@
                   <a:srgbClr val="1A1A1A"/>
                 </a:solidFill>
               </a:rPr>
-              <a:t>Results</a:t>
+              <a:t>Discussion</a:t>
             </a:r>
             <a:endParaRPr lang="en-US" sz="3600" dirty="0"/>
           </a:p>
@@ -3682,7 +2803,7 @@
         <p:spPr>
           <a:xfrm>
             <a:off x="457200" y="274320"/>
-            <a:ext cx="9144000" cy="731520"/>
+            <a:ext cx="7620000" cy="731520"/>
           </a:xfrm>
           <a:prstGeom prst="rect">
             <a:avLst/>
@@ -3698,14 +2819,14 @@
               <a:buNone/>
             </a:pPr>
             <a:r>
-              <a:rPr lang="en-US" sz="2200" b="1" dirty="0">
+              <a:rPr lang="en-US" sz="2400" b="1" dirty="0">
                 <a:solidFill>
                   <a:srgbClr val="1A1A1A"/>
                 </a:solidFill>
               </a:rPr>
-              <a:t>What the data shows</a:t>
-            </a:r>
-            <a:endParaRPr lang="en-US" sz="2200" dirty="0"/>
+              <a:t>What results mean for the field</a:t>
+            </a:r>
+            <a:endParaRPr lang="en-US" sz="2400" dirty="0"/>
           </a:p>
         </p:txBody>
       </p:sp>
@@ -3718,7 +2839,7 @@
         <p:spPr>
           <a:xfrm>
             <a:off x="457200" y="1097280"/>
-            <a:ext cx="9144000" cy="5029200"/>
+            <a:ext cx="7620000" cy="5029200"/>
           </a:xfrm>
           <a:prstGeom prst="rect">
             <a:avLst/>
@@ -3735,14 +2856,14 @@
               <a:buChar char="•"/>
             </a:pPr>
             <a:r>
-              <a:rPr lang="en-US" sz="1400" dirty="0">
+              <a:rPr lang="en-US" sz="1500" dirty="0">
                 <a:solidFill>
                   <a:srgbClr val="1A1A1A"/>
                 </a:solidFill>
               </a:rPr>
-              <a:t>What the data shows</a:t>
-            </a:r>
-            <a:endParaRPr lang="en-US" sz="1400" dirty="0"/>
+              <a:t>What results mean for the field</a:t>
+            </a:r>
+            <a:endParaRPr lang="en-US" sz="1500" dirty="0"/>
           </a:p>
         </p:txBody>
       </p:sp>

</xml_diff>